<commit_message>
added population to the diagram
</commit_message>
<xml_diff>
--- a/DATA604/Project/Team Energy Video Presentation.pptx
+++ b/DATA604/Project/Team Energy Video Presentation.pptx
@@ -137,7 +137,7 @@
 <file path=ppt/revisionInfo.xml><?xml version="1.0" encoding="utf-8"?>
 <p1510:revInfo xmlns:a="http://schemas.openxmlformats.org/drawingml/2006/main" xmlns:r="http://schemas.openxmlformats.org/officeDocument/2006/relationships" xmlns:p1510="http://schemas.microsoft.com/office/powerpoint/2015/10/main">
   <p1510:revLst>
-    <p1510:client id="{867D6758-E00D-441F-8B1D-675252661ABA}" v="5" dt="2025-03-25T21:10:36.997"/>
+    <p1510:client id="{867D6758-E00D-441F-8B1D-675252661ABA}" v="20" dt="2025-03-26T01:23:53.769"/>
   </p1510:revLst>
 </p1510:revInfo>
 </file>
@@ -146,8 +146,8 @@
 <pc:chgInfo xmlns:a="http://schemas.openxmlformats.org/drawingml/2006/main" xmlns:r="http://schemas.openxmlformats.org/officeDocument/2006/relationships" xmlns:ac="http://schemas.microsoft.com/office/drawing/2013/main/command" xmlns:pc="http://schemas.microsoft.com/office/powerpoint/2013/main/command">
   <pc:docChgLst>
     <pc:chgData name="Gautham Nagaraj" userId="42582a7dfd2e08c3" providerId="LiveId" clId="{867D6758-E00D-441F-8B1D-675252661ABA}"/>
-    <pc:docChg chg="custSel modSld">
-      <pc:chgData name="Gautham Nagaraj" userId="42582a7dfd2e08c3" providerId="LiveId" clId="{867D6758-E00D-441F-8B1D-675252661ABA}" dt="2025-03-25T21:15:02.199" v="307" actId="14100"/>
+    <pc:docChg chg="undo custSel modSld">
+      <pc:chgData name="Gautham Nagaraj" userId="42582a7dfd2e08c3" providerId="LiveId" clId="{867D6758-E00D-441F-8B1D-675252661ABA}" dt="2025-03-26T01:23:53.769" v="324" actId="20577"/>
       <pc:docMkLst>
         <pc:docMk/>
       </pc:docMkLst>
@@ -165,6 +165,29 @@
             <ac:spMk id="3" creationId="{2C3485C5-5A29-46EE-605E-6B2194CEA6D7}"/>
           </ac:spMkLst>
         </pc:spChg>
+      </pc:sldChg>
+      <pc:sldChg chg="addSp delSp modSp mod">
+        <pc:chgData name="Gautham Nagaraj" userId="42582a7dfd2e08c3" providerId="LiveId" clId="{867D6758-E00D-441F-8B1D-675252661ABA}" dt="2025-03-26T01:23:53.769" v="324" actId="20577"/>
+        <pc:sldMkLst>
+          <pc:docMk/>
+          <pc:sldMk cId="4275676341" sldId="261"/>
+        </pc:sldMkLst>
+        <pc:graphicFrameChg chg="add del modGraphic">
+          <ac:chgData name="Gautham Nagaraj" userId="42582a7dfd2e08c3" providerId="LiveId" clId="{867D6758-E00D-441F-8B1D-675252661ABA}" dt="2025-03-26T01:23:41.590" v="313" actId="1032"/>
+          <ac:graphicFrameMkLst>
+            <pc:docMk/>
+            <pc:sldMk cId="4275676341" sldId="261"/>
+            <ac:graphicFrameMk id="5" creationId="{4A2F9A63-F84D-107E-891E-4E8C175A203E}"/>
+          </ac:graphicFrameMkLst>
+        </pc:graphicFrameChg>
+        <pc:graphicFrameChg chg="mod">
+          <ac:chgData name="Gautham Nagaraj" userId="42582a7dfd2e08c3" providerId="LiveId" clId="{867D6758-E00D-441F-8B1D-675252661ABA}" dt="2025-03-26T01:23:53.769" v="324" actId="20577"/>
+          <ac:graphicFrameMkLst>
+            <pc:docMk/>
+            <pc:sldMk cId="4275676341" sldId="261"/>
+            <ac:graphicFrameMk id="7" creationId="{84D7C596-CBB8-AF14-38B2-574468B34F80}"/>
+          </ac:graphicFrameMkLst>
+        </pc:graphicFrameChg>
       </pc:sldChg>
       <pc:sldChg chg="addSp delSp modSp mod">
         <pc:chgData name="Gautham Nagaraj" userId="42582a7dfd2e08c3" providerId="LiveId" clId="{867D6758-E00D-441F-8B1D-675252661ABA}" dt="2025-03-25T21:07:56.177" v="59" actId="20577"/>
@@ -1242,6 +1265,29 @@
         </a:p>
       </dgm:t>
     </dgm:pt>
+    <dgm:pt modelId="{5B49F561-1AFD-4951-B3A0-EFFDBBEE9A0A}">
+      <dgm:prSet/>
+      <dgm:spPr/>
+      <dgm:t>
+        <a:bodyPr/>
+        <a:lstStyle/>
+        <a:p>
+          <a:r>
+            <a:rPr lang="en-US" dirty="0"/>
+            <a:t>Population</a:t>
+          </a:r>
+          <a:endParaRPr lang="en-IN" dirty="0"/>
+        </a:p>
+      </dgm:t>
+    </dgm:pt>
+    <dgm:pt modelId="{229A1F36-2F4F-4260-A9C8-510398B1FF57}" type="parTrans" cxnId="{7F45DFC7-3D8E-41C1-BCE9-79231FC0043B}">
+      <dgm:prSet/>
+      <dgm:spPr/>
+    </dgm:pt>
+    <dgm:pt modelId="{F7237934-3951-44C6-B13C-311D776A6FB9}" type="sibTrans" cxnId="{7F45DFC7-3D8E-41C1-BCE9-79231FC0043B}">
+      <dgm:prSet/>
+      <dgm:spPr/>
+    </dgm:pt>
     <dgm:pt modelId="{3E73CF93-6E0B-48EA-80C9-DDDA08E3AF3D}" type="pres">
       <dgm:prSet presAssocID="{09A694BF-E31B-4194-8173-C73AFFB10EF0}" presName="cycle" presStyleCnt="0">
         <dgm:presLayoutVars>
@@ -1258,11 +1304,11 @@
       <dgm:spPr/>
     </dgm:pt>
     <dgm:pt modelId="{9CC0EA03-7B6E-45FA-9656-1879014DA86F}" type="pres">
-      <dgm:prSet presAssocID="{D7A36E3A-B9A8-463B-A850-7E05233330AE}" presName="parTrans" presStyleLbl="bgSibTrans2D1" presStyleIdx="0" presStyleCnt="4"/>
+      <dgm:prSet presAssocID="{D7A36E3A-B9A8-463B-A850-7E05233330AE}" presName="parTrans" presStyleLbl="bgSibTrans2D1" presStyleIdx="0" presStyleCnt="5"/>
       <dgm:spPr/>
     </dgm:pt>
     <dgm:pt modelId="{DB25EE0D-FB1A-4820-A84F-7BA0DCF701A8}" type="pres">
-      <dgm:prSet presAssocID="{03EC52A1-CA8B-48F9-A349-D3FFD6845494}" presName="node" presStyleLbl="node1" presStyleIdx="0" presStyleCnt="4">
+      <dgm:prSet presAssocID="{03EC52A1-CA8B-48F9-A349-D3FFD6845494}" presName="node" presStyleLbl="node1" presStyleIdx="0" presStyleCnt="5">
         <dgm:presLayoutVars>
           <dgm:bulletEnabled val="1"/>
         </dgm:presLayoutVars>
@@ -1270,11 +1316,11 @@
       <dgm:spPr/>
     </dgm:pt>
     <dgm:pt modelId="{C033710C-FBA9-4612-A979-DBBFD2FDAF48}" type="pres">
-      <dgm:prSet presAssocID="{26AA57B9-097B-47DD-8A75-EFC05257DD8B}" presName="parTrans" presStyleLbl="bgSibTrans2D1" presStyleIdx="1" presStyleCnt="4"/>
+      <dgm:prSet presAssocID="{26AA57B9-097B-47DD-8A75-EFC05257DD8B}" presName="parTrans" presStyleLbl="bgSibTrans2D1" presStyleIdx="1" presStyleCnt="5"/>
       <dgm:spPr/>
     </dgm:pt>
     <dgm:pt modelId="{A6150D1F-5B97-42C3-91CE-D898E60FE0BB}" type="pres">
-      <dgm:prSet presAssocID="{50EF196C-85E1-435C-A6CA-E3A52D27105F}" presName="node" presStyleLbl="node1" presStyleIdx="1" presStyleCnt="4">
+      <dgm:prSet presAssocID="{50EF196C-85E1-435C-A6CA-E3A52D27105F}" presName="node" presStyleLbl="node1" presStyleIdx="1" presStyleCnt="5">
         <dgm:presLayoutVars>
           <dgm:bulletEnabled val="1"/>
         </dgm:presLayoutVars>
@@ -1282,11 +1328,11 @@
       <dgm:spPr/>
     </dgm:pt>
     <dgm:pt modelId="{9DFCF696-075F-445B-B3E5-C48E6DB8894D}" type="pres">
-      <dgm:prSet presAssocID="{CDED4B29-0C6A-4120-981F-E0EBB120CBBB}" presName="parTrans" presStyleLbl="bgSibTrans2D1" presStyleIdx="2" presStyleCnt="4"/>
+      <dgm:prSet presAssocID="{CDED4B29-0C6A-4120-981F-E0EBB120CBBB}" presName="parTrans" presStyleLbl="bgSibTrans2D1" presStyleIdx="2" presStyleCnt="5"/>
       <dgm:spPr/>
     </dgm:pt>
     <dgm:pt modelId="{996C32D0-FF0E-45B5-9D6F-67FC5F79E0E0}" type="pres">
-      <dgm:prSet presAssocID="{20BA2C77-C309-4B7E-9ACA-6C7C31E28F86}" presName="node" presStyleLbl="node1" presStyleIdx="2" presStyleCnt="4">
+      <dgm:prSet presAssocID="{20BA2C77-C309-4B7E-9ACA-6C7C31E28F86}" presName="node" presStyleLbl="node1" presStyleIdx="2" presStyleCnt="5">
         <dgm:presLayoutVars>
           <dgm:bulletEnabled val="1"/>
         </dgm:presLayoutVars>
@@ -1294,11 +1340,23 @@
       <dgm:spPr/>
     </dgm:pt>
     <dgm:pt modelId="{7916A645-8AF9-4A21-8463-950CB0F8B5DA}" type="pres">
-      <dgm:prSet presAssocID="{C9733C47-05D5-4AFD-9D0F-6FDD1F3F84A4}" presName="parTrans" presStyleLbl="bgSibTrans2D1" presStyleIdx="3" presStyleCnt="4"/>
+      <dgm:prSet presAssocID="{C9733C47-05D5-4AFD-9D0F-6FDD1F3F84A4}" presName="parTrans" presStyleLbl="bgSibTrans2D1" presStyleIdx="3" presStyleCnt="5"/>
       <dgm:spPr/>
     </dgm:pt>
     <dgm:pt modelId="{7586EB83-09FF-4C94-BC12-29CF77DDC1AA}" type="pres">
-      <dgm:prSet presAssocID="{B307D585-AD02-4431-89ED-E3C2783794C1}" presName="node" presStyleLbl="node1" presStyleIdx="3" presStyleCnt="4">
+      <dgm:prSet presAssocID="{B307D585-AD02-4431-89ED-E3C2783794C1}" presName="node" presStyleLbl="node1" presStyleIdx="3" presStyleCnt="5">
+        <dgm:presLayoutVars>
+          <dgm:bulletEnabled val="1"/>
+        </dgm:presLayoutVars>
+      </dgm:prSet>
+      <dgm:spPr/>
+    </dgm:pt>
+    <dgm:pt modelId="{F4BD996A-18D7-43AF-AFFB-0E14C0F2D55C}" type="pres">
+      <dgm:prSet presAssocID="{229A1F36-2F4F-4260-A9C8-510398B1FF57}" presName="parTrans" presStyleLbl="bgSibTrans2D1" presStyleIdx="4" presStyleCnt="5"/>
+      <dgm:spPr/>
+    </dgm:pt>
+    <dgm:pt modelId="{9BCF24D6-1475-4CB3-8721-DF6FE7910013}" type="pres">
+      <dgm:prSet presAssocID="{5B49F561-1AFD-4951-B3A0-EFFDBBEE9A0A}" presName="node" presStyleLbl="node1" presStyleIdx="4" presStyleCnt="5">
         <dgm:presLayoutVars>
           <dgm:bulletEnabled val="1"/>
         </dgm:presLayoutVars>
@@ -1308,6 +1366,7 @@
   </dgm:ptLst>
   <dgm:cxnLst>
     <dgm:cxn modelId="{5DAD4B08-ED50-458E-957F-B8F9EB1C3769}" type="presOf" srcId="{26AA57B9-097B-47DD-8A75-EFC05257DD8B}" destId="{C033710C-FBA9-4612-A979-DBBFD2FDAF48}" srcOrd="0" destOrd="0" presId="urn:microsoft.com/office/officeart/2005/8/layout/radial4"/>
+    <dgm:cxn modelId="{9C42D30C-0652-4062-8827-B892F6255D7D}" type="presOf" srcId="{229A1F36-2F4F-4260-A9C8-510398B1FF57}" destId="{F4BD996A-18D7-43AF-AFFB-0E14C0F2D55C}" srcOrd="0" destOrd="0" presId="urn:microsoft.com/office/officeart/2005/8/layout/radial4"/>
     <dgm:cxn modelId="{4BAC8326-47C5-45BB-8F13-1FEA39198D26}" srcId="{96BBCA28-5276-4D61-AF8B-BC9EFFBBF63D}" destId="{03EC52A1-CA8B-48F9-A349-D3FFD6845494}" srcOrd="0" destOrd="0" parTransId="{D7A36E3A-B9A8-463B-A850-7E05233330AE}" sibTransId="{AC305EBF-AA98-4C4D-A4F1-4CEA4D72DC82}"/>
     <dgm:cxn modelId="{73C1FC2C-9C6C-4734-880F-200341FFC0A5}" type="presOf" srcId="{20BA2C77-C309-4B7E-9ACA-6C7C31E28F86}" destId="{996C32D0-FF0E-45B5-9D6F-67FC5F79E0E0}" srcOrd="0" destOrd="0" presId="urn:microsoft.com/office/officeart/2005/8/layout/radial4"/>
     <dgm:cxn modelId="{F234CC3B-281A-4449-AB44-3289FAEB550B}" type="presOf" srcId="{96BBCA28-5276-4D61-AF8B-BC9EFFBBF63D}" destId="{2CBC1EEB-8FBE-4124-8B1F-DACA857EE920}" srcOrd="0" destOrd="0" presId="urn:microsoft.com/office/officeart/2005/8/layout/radial4"/>
@@ -1319,7 +1378,9 @@
     <dgm:cxn modelId="{F3FEFC88-284E-422D-A3D4-D5E15CB0070F}" srcId="{09A694BF-E31B-4194-8173-C73AFFB10EF0}" destId="{96BBCA28-5276-4D61-AF8B-BC9EFFBBF63D}" srcOrd="0" destOrd="0" parTransId="{F11A2EA6-1902-4B15-906A-E041FAAE7F8C}" sibTransId="{754B0487-1229-4D2F-9750-F4C3AA88EB5B}"/>
     <dgm:cxn modelId="{B73193A8-01CD-4393-90B0-6969429E8743}" type="presOf" srcId="{D7A36E3A-B9A8-463B-A850-7E05233330AE}" destId="{9CC0EA03-7B6E-45FA-9656-1879014DA86F}" srcOrd="0" destOrd="0" presId="urn:microsoft.com/office/officeart/2005/8/layout/radial4"/>
     <dgm:cxn modelId="{70A60FAE-7BC4-42A3-8F83-B45FE7C2A9F0}" type="presOf" srcId="{03EC52A1-CA8B-48F9-A349-D3FFD6845494}" destId="{DB25EE0D-FB1A-4820-A84F-7BA0DCF701A8}" srcOrd="0" destOrd="0" presId="urn:microsoft.com/office/officeart/2005/8/layout/radial4"/>
+    <dgm:cxn modelId="{37BA8FBA-64AB-4636-AC6A-07592F1E880A}" type="presOf" srcId="{5B49F561-1AFD-4951-B3A0-EFFDBBEE9A0A}" destId="{9BCF24D6-1475-4CB3-8721-DF6FE7910013}" srcOrd="0" destOrd="0" presId="urn:microsoft.com/office/officeart/2005/8/layout/radial4"/>
     <dgm:cxn modelId="{FB8CD5BB-2638-4BE0-B4BA-06EA5E41D29C}" type="presOf" srcId="{CDED4B29-0C6A-4120-981F-E0EBB120CBBB}" destId="{9DFCF696-075F-445B-B3E5-C48E6DB8894D}" srcOrd="0" destOrd="0" presId="urn:microsoft.com/office/officeart/2005/8/layout/radial4"/>
+    <dgm:cxn modelId="{7F45DFC7-3D8E-41C1-BCE9-79231FC0043B}" srcId="{96BBCA28-5276-4D61-AF8B-BC9EFFBBF63D}" destId="{5B49F561-1AFD-4951-B3A0-EFFDBBEE9A0A}" srcOrd="4" destOrd="0" parTransId="{229A1F36-2F4F-4260-A9C8-510398B1FF57}" sibTransId="{F7237934-3951-44C6-B13C-311D776A6FB9}"/>
     <dgm:cxn modelId="{58BB7BF7-11AC-4FEC-B35A-E16669570EB7}" type="presOf" srcId="{50EF196C-85E1-435C-A6CA-E3A52D27105F}" destId="{A6150D1F-5B97-42C3-91CE-D898E60FE0BB}" srcOrd="0" destOrd="0" presId="urn:microsoft.com/office/officeart/2005/8/layout/radial4"/>
     <dgm:cxn modelId="{1EBC2CF8-48D6-4254-B2BE-3114C1CE4E81}" type="presOf" srcId="{09A694BF-E31B-4194-8173-C73AFFB10EF0}" destId="{3E73CF93-6E0B-48EA-80C9-DDDA08E3AF3D}" srcOrd="0" destOrd="0" presId="urn:microsoft.com/office/officeart/2005/8/layout/radial4"/>
     <dgm:cxn modelId="{D1D19729-9809-4A8E-BC40-9EF711CF1EC7}" type="presParOf" srcId="{3E73CF93-6E0B-48EA-80C9-DDDA08E3AF3D}" destId="{2CBC1EEB-8FBE-4124-8B1F-DACA857EE920}" srcOrd="0" destOrd="0" presId="urn:microsoft.com/office/officeart/2005/8/layout/radial4"/>
@@ -1331,6 +1392,8 @@
     <dgm:cxn modelId="{DCA3214C-EA5C-4985-9C2B-E0F903C77251}" type="presParOf" srcId="{3E73CF93-6E0B-48EA-80C9-DDDA08E3AF3D}" destId="{996C32D0-FF0E-45B5-9D6F-67FC5F79E0E0}" srcOrd="6" destOrd="0" presId="urn:microsoft.com/office/officeart/2005/8/layout/radial4"/>
     <dgm:cxn modelId="{0C64D8EE-A761-4262-BD1C-7B0FCD2CE064}" type="presParOf" srcId="{3E73CF93-6E0B-48EA-80C9-DDDA08E3AF3D}" destId="{7916A645-8AF9-4A21-8463-950CB0F8B5DA}" srcOrd="7" destOrd="0" presId="urn:microsoft.com/office/officeart/2005/8/layout/radial4"/>
     <dgm:cxn modelId="{C7A86A53-19B1-435B-AEF6-D1D0ECCB677E}" type="presParOf" srcId="{3E73CF93-6E0B-48EA-80C9-DDDA08E3AF3D}" destId="{7586EB83-09FF-4C94-BC12-29CF77DDC1AA}" srcOrd="8" destOrd="0" presId="urn:microsoft.com/office/officeart/2005/8/layout/radial4"/>
+    <dgm:cxn modelId="{51F8370F-20B3-4CFB-8C8C-DD1B5B98F7B9}" type="presParOf" srcId="{3E73CF93-6E0B-48EA-80C9-DDDA08E3AF3D}" destId="{F4BD996A-18D7-43AF-AFFB-0E14C0F2D55C}" srcOrd="9" destOrd="0" presId="urn:microsoft.com/office/officeart/2005/8/layout/radial4"/>
+    <dgm:cxn modelId="{E6719946-58F0-4605-A7B8-2D453920EC1B}" type="presParOf" srcId="{3E73CF93-6E0B-48EA-80C9-DDDA08E3AF3D}" destId="{9BCF24D6-1475-4CB3-8721-DF6FE7910013}" srcOrd="10" destOrd="0" presId="urn:microsoft.com/office/officeart/2005/8/layout/radial4"/>
   </dgm:cxnLst>
   <dgm:bg/>
   <dgm:whole/>
@@ -1357,8 +1420,8 @@
       </dsp:nvSpPr>
       <dsp:spPr>
         <a:xfrm>
-          <a:off x="2634023" y="2421787"/>
-          <a:ext cx="1948455" cy="1948455"/>
+          <a:off x="2679690" y="2577709"/>
+          <a:ext cx="1857121" cy="1857121"/>
         </a:xfrm>
         <a:prstGeom prst="ellipse">
           <a:avLst/>
@@ -1400,12 +1463,12 @@
         </a:fontRef>
       </dsp:style>
       <dsp:txBody>
-        <a:bodyPr spcFirstLastPara="0" vert="horz" wrap="square" lIns="32385" tIns="32385" rIns="32385" bIns="32385" numCol="1" spcCol="1270" anchor="ctr" anchorCtr="0">
+        <a:bodyPr spcFirstLastPara="0" vert="horz" wrap="square" lIns="30480" tIns="30480" rIns="30480" bIns="30480" numCol="1" spcCol="1270" anchor="ctr" anchorCtr="0">
           <a:noAutofit/>
         </a:bodyPr>
         <a:lstStyle/>
         <a:p>
-          <a:pPr marL="0" lvl="0" indent="0" algn="ctr" defTabSz="2266950">
+          <a:pPr marL="0" lvl="0" indent="0" algn="ctr" defTabSz="2133600">
             <a:lnSpc>
               <a:spcPct val="90000"/>
             </a:lnSpc>
@@ -1418,15 +1481,15 @@
             <a:buNone/>
           </a:pPr>
           <a:r>
-            <a:rPr lang="en-US" sz="5100" kern="1200" dirty="0"/>
+            <a:rPr lang="en-US" sz="4800" kern="1200" dirty="0"/>
             <a:t>Price</a:t>
           </a:r>
-          <a:endParaRPr lang="en-IN" sz="5100" kern="1200" dirty="0"/>
+          <a:endParaRPr lang="en-IN" sz="4800" kern="1200" dirty="0"/>
         </a:p>
       </dsp:txBody>
       <dsp:txXfrm>
-        <a:off x="2919368" y="2707132"/>
-        <a:ext cx="1377765" cy="1377765"/>
+        <a:off x="2951659" y="2849678"/>
+        <a:ext cx="1313183" cy="1313183"/>
       </dsp:txXfrm>
     </dsp:sp>
     <dsp:sp modelId="{9CC0EA03-7B6E-45FA-9656-1879014DA86F}">
@@ -1435,9 +1498,9 @@
         <dsp:cNvSpPr/>
       </dsp:nvSpPr>
       <dsp:spPr>
-        <a:xfrm rot="11700000">
-          <a:off x="897718" y="2620205"/>
-          <a:ext cx="1702784" cy="555309"/>
+        <a:xfrm rot="10800000">
+          <a:off x="882685" y="3241630"/>
+          <a:ext cx="1698169" cy="529279"/>
         </a:xfrm>
         <a:prstGeom prst="leftArrow">
           <a:avLst>
@@ -1481,8 +1544,8 @@
       </dsp:nvSpPr>
       <dsp:spPr>
         <a:xfrm>
-          <a:off x="1212" y="1937090"/>
-          <a:ext cx="1851033" cy="1480826"/>
+          <a:off x="552" y="2800564"/>
+          <a:ext cx="1764265" cy="1411412"/>
         </a:xfrm>
         <a:prstGeom prst="roundRect">
           <a:avLst>
@@ -1526,12 +1589,12 @@
         </a:fontRef>
       </dsp:style>
       <dsp:txBody>
-        <a:bodyPr spcFirstLastPara="0" vert="horz" wrap="square" lIns="47625" tIns="47625" rIns="47625" bIns="47625" numCol="1" spcCol="1270" anchor="ctr" anchorCtr="0">
+        <a:bodyPr spcFirstLastPara="0" vert="horz" wrap="square" lIns="45720" tIns="45720" rIns="45720" bIns="45720" numCol="1" spcCol="1270" anchor="ctr" anchorCtr="0">
           <a:noAutofit/>
         </a:bodyPr>
         <a:lstStyle/>
         <a:p>
-          <a:pPr marL="0" lvl="0" indent="0" algn="ctr" defTabSz="1111250">
+          <a:pPr marL="0" lvl="0" indent="0" algn="ctr" defTabSz="1066800">
             <a:lnSpc>
               <a:spcPct val="90000"/>
             </a:lnSpc>
@@ -1544,15 +1607,15 @@
             <a:buNone/>
           </a:pPr>
           <a:r>
-            <a:rPr lang="en-US" sz="2500" kern="1200" dirty="0"/>
+            <a:rPr lang="en-US" sz="2400" kern="1200" dirty="0"/>
             <a:t>Demand</a:t>
           </a:r>
-          <a:endParaRPr lang="en-IN" sz="2500" kern="1200" dirty="0"/>
+          <a:endParaRPr lang="en-IN" sz="2400" kern="1200" dirty="0"/>
         </a:p>
       </dsp:txBody>
       <dsp:txXfrm>
-        <a:off x="44584" y="1980462"/>
-        <a:ext cx="1764289" cy="1394082"/>
+        <a:off x="41891" y="2841903"/>
+        <a:ext cx="1681587" cy="1328734"/>
       </dsp:txXfrm>
     </dsp:sp>
     <dsp:sp modelId="{C033710C-FBA9-4612-A979-DBBFD2FDAF48}">
@@ -1561,9 +1624,9 @@
         <dsp:cNvSpPr/>
       </dsp:nvSpPr>
       <dsp:spPr>
-        <a:xfrm rot="14700000">
-          <a:off x="1943435" y="1373968"/>
-          <a:ext cx="1702784" cy="555309"/>
+        <a:xfrm rot="13500000">
+          <a:off x="1432294" y="1914758"/>
+          <a:ext cx="1698169" cy="529279"/>
         </a:xfrm>
         <a:prstGeom prst="leftArrow">
           <a:avLst>
@@ -1607,8 +1670,8 @@
       </dsp:nvSpPr>
       <dsp:spPr>
         <a:xfrm>
-          <a:off x="1509497" y="139586"/>
-          <a:ext cx="1851033" cy="1480826"/>
+          <a:off x="798852" y="873298"/>
+          <a:ext cx="1764265" cy="1411412"/>
         </a:xfrm>
         <a:prstGeom prst="roundRect">
           <a:avLst>
@@ -1652,12 +1715,12 @@
         </a:fontRef>
       </dsp:style>
       <dsp:txBody>
-        <a:bodyPr spcFirstLastPara="0" vert="horz" wrap="square" lIns="47625" tIns="47625" rIns="47625" bIns="47625" numCol="1" spcCol="1270" anchor="ctr" anchorCtr="0">
+        <a:bodyPr spcFirstLastPara="0" vert="horz" wrap="square" lIns="45720" tIns="45720" rIns="45720" bIns="45720" numCol="1" spcCol="1270" anchor="ctr" anchorCtr="0">
           <a:noAutofit/>
         </a:bodyPr>
         <a:lstStyle/>
         <a:p>
-          <a:pPr marL="0" lvl="0" indent="0" algn="ctr" defTabSz="1111250">
+          <a:pPr marL="0" lvl="0" indent="0" algn="ctr" defTabSz="1066800">
             <a:lnSpc>
               <a:spcPct val="90000"/>
             </a:lnSpc>
@@ -1670,15 +1733,15 @@
             <a:buNone/>
           </a:pPr>
           <a:r>
-            <a:rPr lang="en-US" sz="2500" kern="1200" dirty="0"/>
+            <a:rPr lang="en-US" sz="2400" kern="1200" dirty="0"/>
             <a:t>Temperature</a:t>
           </a:r>
-          <a:endParaRPr lang="en-IN" sz="2500" kern="1200" dirty="0"/>
+          <a:endParaRPr lang="en-IN" sz="2400" kern="1200" dirty="0"/>
         </a:p>
       </dsp:txBody>
       <dsp:txXfrm>
-        <a:off x="1552869" y="182958"/>
-        <a:ext cx="1764289" cy="1394082"/>
+        <a:off x="840191" y="914637"/>
+        <a:ext cx="1681587" cy="1328734"/>
       </dsp:txXfrm>
     </dsp:sp>
     <dsp:sp modelId="{9DFCF696-075F-445B-B3E5-C48E6DB8894D}">
@@ -1687,9 +1750,9 @@
         <dsp:cNvSpPr/>
       </dsp:nvSpPr>
       <dsp:spPr>
-        <a:xfrm rot="17700000">
-          <a:off x="3570282" y="1373968"/>
-          <a:ext cx="1702784" cy="555309"/>
+        <a:xfrm rot="16200000">
+          <a:off x="2759166" y="1365149"/>
+          <a:ext cx="1698169" cy="529279"/>
         </a:xfrm>
         <a:prstGeom prst="leftArrow">
           <a:avLst>
@@ -1733,8 +1796,8 @@
       </dsp:nvSpPr>
       <dsp:spPr>
         <a:xfrm>
-          <a:off x="3855972" y="139586"/>
-          <a:ext cx="1851033" cy="1480826"/>
+          <a:off x="2726118" y="74998"/>
+          <a:ext cx="1764265" cy="1411412"/>
         </a:xfrm>
         <a:prstGeom prst="roundRect">
           <a:avLst>
@@ -1778,12 +1841,12 @@
         </a:fontRef>
       </dsp:style>
       <dsp:txBody>
-        <a:bodyPr spcFirstLastPara="0" vert="horz" wrap="square" lIns="47625" tIns="47625" rIns="47625" bIns="47625" numCol="1" spcCol="1270" anchor="ctr" anchorCtr="0">
+        <a:bodyPr spcFirstLastPara="0" vert="horz" wrap="square" lIns="45720" tIns="45720" rIns="45720" bIns="45720" numCol="1" spcCol="1270" anchor="ctr" anchorCtr="0">
           <a:noAutofit/>
         </a:bodyPr>
         <a:lstStyle/>
         <a:p>
-          <a:pPr marL="0" lvl="0" indent="0" algn="ctr" defTabSz="1111250">
+          <a:pPr marL="0" lvl="0" indent="0" algn="ctr" defTabSz="1066800">
             <a:lnSpc>
               <a:spcPct val="90000"/>
             </a:lnSpc>
@@ -1796,15 +1859,15 @@
             <a:buNone/>
           </a:pPr>
           <a:r>
-            <a:rPr lang="en-US" sz="2500" kern="1200" dirty="0"/>
+            <a:rPr lang="en-US" sz="2400" kern="1200" dirty="0"/>
             <a:t>Gas Price</a:t>
           </a:r>
-          <a:endParaRPr lang="en-IN" sz="2500" kern="1200" dirty="0"/>
+          <a:endParaRPr lang="en-IN" sz="2400" kern="1200" dirty="0"/>
         </a:p>
       </dsp:txBody>
       <dsp:txXfrm>
-        <a:off x="3899344" y="182958"/>
-        <a:ext cx="1764289" cy="1394082"/>
+        <a:off x="2767457" y="116337"/>
+        <a:ext cx="1681587" cy="1328734"/>
       </dsp:txXfrm>
     </dsp:sp>
     <dsp:sp modelId="{7916A645-8AF9-4A21-8463-950CB0F8B5DA}">
@@ -1813,9 +1876,9 @@
         <dsp:cNvSpPr/>
       </dsp:nvSpPr>
       <dsp:spPr>
-        <a:xfrm rot="20700000">
-          <a:off x="4615999" y="2620205"/>
-          <a:ext cx="1702784" cy="555309"/>
+        <a:xfrm rot="18900000">
+          <a:off x="4086039" y="1914758"/>
+          <a:ext cx="1698169" cy="529279"/>
         </a:xfrm>
         <a:prstGeom prst="leftArrow">
           <a:avLst>
@@ -1859,8 +1922,8 @@
       </dsp:nvSpPr>
       <dsp:spPr>
         <a:xfrm>
-          <a:off x="5364257" y="1937090"/>
-          <a:ext cx="1851033" cy="1480826"/>
+          <a:off x="4653384" y="873298"/>
+          <a:ext cx="1764265" cy="1411412"/>
         </a:xfrm>
         <a:prstGeom prst="roundRect">
           <a:avLst>
@@ -1904,12 +1967,12 @@
         </a:fontRef>
       </dsp:style>
       <dsp:txBody>
-        <a:bodyPr spcFirstLastPara="0" vert="horz" wrap="square" lIns="47625" tIns="47625" rIns="47625" bIns="47625" numCol="1" spcCol="1270" anchor="ctr" anchorCtr="0">
+        <a:bodyPr spcFirstLastPara="0" vert="horz" wrap="square" lIns="45720" tIns="45720" rIns="45720" bIns="45720" numCol="1" spcCol="1270" anchor="ctr" anchorCtr="0">
           <a:noAutofit/>
         </a:bodyPr>
         <a:lstStyle/>
         <a:p>
-          <a:pPr marL="0" lvl="0" indent="0" algn="ctr" defTabSz="1111250">
+          <a:pPr marL="0" lvl="0" indent="0" algn="ctr" defTabSz="1066800">
             <a:lnSpc>
               <a:spcPct val="90000"/>
             </a:lnSpc>
@@ -1922,15 +1985,141 @@
             <a:buNone/>
           </a:pPr>
           <a:r>
-            <a:rPr lang="en-US" sz="2500" kern="1200" dirty="0"/>
+            <a:rPr lang="en-US" sz="2400" kern="1200" dirty="0"/>
             <a:t>Generation</a:t>
           </a:r>
-          <a:endParaRPr lang="en-IN" sz="2500" kern="1200" dirty="0"/>
+          <a:endParaRPr lang="en-IN" sz="2400" kern="1200" dirty="0"/>
         </a:p>
       </dsp:txBody>
       <dsp:txXfrm>
-        <a:off x="5407629" y="1980462"/>
-        <a:ext cx="1764289" cy="1394082"/>
+        <a:off x="4694723" y="914637"/>
+        <a:ext cx="1681587" cy="1328734"/>
+      </dsp:txXfrm>
+    </dsp:sp>
+    <dsp:sp modelId="{F4BD996A-18D7-43AF-AFFB-0E14C0F2D55C}">
+      <dsp:nvSpPr>
+        <dsp:cNvPr id="0" name=""/>
+        <dsp:cNvSpPr/>
+      </dsp:nvSpPr>
+      <dsp:spPr>
+        <a:xfrm>
+          <a:off x="4635647" y="3241630"/>
+          <a:ext cx="1698169" cy="529279"/>
+        </a:xfrm>
+        <a:prstGeom prst="leftArrow">
+          <a:avLst>
+            <a:gd name="adj1" fmla="val 60000"/>
+            <a:gd name="adj2" fmla="val 50000"/>
+          </a:avLst>
+        </a:prstGeom>
+        <a:solidFill>
+          <a:schemeClr val="accent1">
+            <a:tint val="60000"/>
+            <a:hueOff val="0"/>
+            <a:satOff val="0"/>
+            <a:lumOff val="0"/>
+            <a:alphaOff val="0"/>
+          </a:schemeClr>
+        </a:solidFill>
+        <a:ln>
+          <a:noFill/>
+        </a:ln>
+        <a:effectLst/>
+      </dsp:spPr>
+      <dsp:style>
+        <a:lnRef idx="0">
+          <a:scrgbClr r="0" g="0" b="0"/>
+        </a:lnRef>
+        <a:fillRef idx="1">
+          <a:scrgbClr r="0" g="0" b="0"/>
+        </a:fillRef>
+        <a:effectRef idx="0">
+          <a:scrgbClr r="0" g="0" b="0"/>
+        </a:effectRef>
+        <a:fontRef idx="minor">
+          <a:schemeClr val="lt1"/>
+        </a:fontRef>
+      </dsp:style>
+    </dsp:sp>
+    <dsp:sp modelId="{9BCF24D6-1475-4CB3-8721-DF6FE7910013}">
+      <dsp:nvSpPr>
+        <dsp:cNvPr id="0" name=""/>
+        <dsp:cNvSpPr/>
+      </dsp:nvSpPr>
+      <dsp:spPr>
+        <a:xfrm>
+          <a:off x="5451684" y="2800564"/>
+          <a:ext cx="1764265" cy="1411412"/>
+        </a:xfrm>
+        <a:prstGeom prst="roundRect">
+          <a:avLst>
+            <a:gd name="adj" fmla="val 10000"/>
+          </a:avLst>
+        </a:prstGeom>
+        <a:solidFill>
+          <a:schemeClr val="accent1">
+            <a:hueOff val="0"/>
+            <a:satOff val="0"/>
+            <a:lumOff val="0"/>
+            <a:alphaOff val="0"/>
+          </a:schemeClr>
+        </a:solidFill>
+        <a:ln w="12700" cap="flat" cmpd="sng" algn="ctr">
+          <a:solidFill>
+            <a:schemeClr val="lt1">
+              <a:hueOff val="0"/>
+              <a:satOff val="0"/>
+              <a:lumOff val="0"/>
+              <a:alphaOff val="0"/>
+            </a:schemeClr>
+          </a:solidFill>
+          <a:prstDash val="solid"/>
+          <a:miter lim="800000"/>
+        </a:ln>
+        <a:effectLst/>
+      </dsp:spPr>
+      <dsp:style>
+        <a:lnRef idx="2">
+          <a:scrgbClr r="0" g="0" b="0"/>
+        </a:lnRef>
+        <a:fillRef idx="1">
+          <a:scrgbClr r="0" g="0" b="0"/>
+        </a:fillRef>
+        <a:effectRef idx="0">
+          <a:scrgbClr r="0" g="0" b="0"/>
+        </a:effectRef>
+        <a:fontRef idx="minor">
+          <a:schemeClr val="lt1"/>
+        </a:fontRef>
+      </dsp:style>
+      <dsp:txBody>
+        <a:bodyPr spcFirstLastPara="0" vert="horz" wrap="square" lIns="45720" tIns="45720" rIns="45720" bIns="45720" numCol="1" spcCol="1270" anchor="ctr" anchorCtr="0">
+          <a:noAutofit/>
+        </a:bodyPr>
+        <a:lstStyle/>
+        <a:p>
+          <a:pPr marL="0" lvl="0" indent="0" algn="ctr" defTabSz="1066800">
+            <a:lnSpc>
+              <a:spcPct val="90000"/>
+            </a:lnSpc>
+            <a:spcBef>
+              <a:spcPct val="0"/>
+            </a:spcBef>
+            <a:spcAft>
+              <a:spcPct val="35000"/>
+            </a:spcAft>
+            <a:buNone/>
+          </a:pPr>
+          <a:r>
+            <a:rPr lang="en-US" sz="2400" kern="1200" dirty="0"/>
+            <a:t>Population</a:t>
+          </a:r>
+          <a:endParaRPr lang="en-IN" sz="2400" kern="1200" dirty="0"/>
+        </a:p>
+      </dsp:txBody>
+      <dsp:txXfrm>
+        <a:off x="5493023" y="2841903"/>
+        <a:ext cx="1681587" cy="1328734"/>
       </dsp:txXfrm>
     </dsp:sp>
   </dsp:spTree>
@@ -6785,7 +6974,7 @@
           <p:nvPr>
             <p:extLst>
               <p:ext uri="{D42A27DB-BD31-4B8C-83A1-F6EECF244321}">
-                <p14:modId xmlns:p14="http://schemas.microsoft.com/office/powerpoint/2010/main" val="3008081401"/>
+                <p14:modId xmlns:p14="http://schemas.microsoft.com/office/powerpoint/2010/main" val="3257354709"/>
               </p:ext>
             </p:extLst>
           </p:nvPr>
@@ -8175,6 +8364,29 @@
 </file>
 
 <file path=customXml/item1.xml><?xml version="1.0" encoding="utf-8"?>
+<p:properties xmlns:p="http://schemas.microsoft.com/office/2006/metadata/properties" xmlns:xsi="http://www.w3.org/2001/XMLSchema-instance" xmlns:pc="http://schemas.microsoft.com/office/infopath/2007/PartnerControls">
+  <documentManagement>
+    <SharedWithUsers xmlns="7a4191d5-9b76-4ae3-8401-87ceee92a846">
+      <UserInfo>
+        <DisplayName>Office Of Advancement Visitors</DisplayName>
+        <AccountId>4</AccountId>
+        <AccountType/>
+      </UserInfo>
+      <UserInfo>
+        <DisplayName>UCalgary Brand</DisplayName>
+        <AccountId>15</AccountId>
+        <AccountType/>
+      </UserInfo>
+    </SharedWithUsers>
+    <TaxCatchAll xmlns="7a4191d5-9b76-4ae3-8401-87ceee92a846" xsi:nil="true"/>
+    <lcf76f155ced4ddcb4097134ff3c332f xmlns="b9b0194d-1e98-4efc-bad5-9450f4bf7a13">
+      <Terms xmlns="http://schemas.microsoft.com/office/infopath/2007/PartnerControls"/>
+    </lcf76f155ced4ddcb4097134ff3c332f>
+  </documentManagement>
+</p:properties>
+</file>
+
+<file path=customXml/item2.xml><?xml version="1.0" encoding="utf-8"?>
 <ct:contentTypeSchema xmlns:ct="http://schemas.microsoft.com/office/2006/metadata/contentType" xmlns:ma="http://schemas.microsoft.com/office/2006/metadata/properties/metaAttributes" ct:_="" ma:_="" ma:contentTypeName="Document" ma:contentTypeID="0x010100A14D9A0FA515564792FEACC70AB1043E" ma:contentTypeVersion="15" ma:contentTypeDescription="Create a new document." ma:contentTypeScope="" ma:versionID="3387522b3212352fc6bbea455d3cfc53">
   <xsd:schema xmlns:xsd="http://www.w3.org/2001/XMLSchema" xmlns:xs="http://www.w3.org/2001/XMLSchema" xmlns:p="http://schemas.microsoft.com/office/2006/metadata/properties" xmlns:ns2="7a4191d5-9b76-4ae3-8401-87ceee92a846" xmlns:ns3="b9b0194d-1e98-4efc-bad5-9450f4bf7a13" targetNamespace="http://schemas.microsoft.com/office/2006/metadata/properties" ma:root="true" ma:fieldsID="e28e2b4de73025e43726d49ef756c6aa" ns2:_="" ns3:_="">
     <xsd:import namespace="7a4191d5-9b76-4ae3-8401-87ceee92a846"/>
@@ -8397,29 +8609,6 @@
 </ct:contentTypeSchema>
 </file>
 
-<file path=customXml/item2.xml><?xml version="1.0" encoding="utf-8"?>
-<p:properties xmlns:p="http://schemas.microsoft.com/office/2006/metadata/properties" xmlns:xsi="http://www.w3.org/2001/XMLSchema-instance" xmlns:pc="http://schemas.microsoft.com/office/infopath/2007/PartnerControls">
-  <documentManagement>
-    <SharedWithUsers xmlns="7a4191d5-9b76-4ae3-8401-87ceee92a846">
-      <UserInfo>
-        <DisplayName>Office Of Advancement Visitors</DisplayName>
-        <AccountId>4</AccountId>
-        <AccountType/>
-      </UserInfo>
-      <UserInfo>
-        <DisplayName>UCalgary Brand</DisplayName>
-        <AccountId>15</AccountId>
-        <AccountType/>
-      </UserInfo>
-    </SharedWithUsers>
-    <TaxCatchAll xmlns="7a4191d5-9b76-4ae3-8401-87ceee92a846" xsi:nil="true"/>
-    <lcf76f155ced4ddcb4097134ff3c332f xmlns="b9b0194d-1e98-4efc-bad5-9450f4bf7a13">
-      <Terms xmlns="http://schemas.microsoft.com/office/infopath/2007/PartnerControls"/>
-    </lcf76f155ced4ddcb4097134ff3c332f>
-  </documentManagement>
-</p:properties>
-</file>
-
 <file path=customXml/item3.xml><?xml version="1.0" encoding="utf-8"?>
 <?mso-contentType ?>
 <FormTemplates xmlns="http://schemas.microsoft.com/sharepoint/v3/contenttype/forms">
@@ -8430,6 +8619,17 @@
 </file>
 
 <file path=customXml/itemProps1.xml><?xml version="1.0" encoding="utf-8"?>
+<ds:datastoreItem xmlns:ds="http://schemas.openxmlformats.org/officeDocument/2006/customXml" ds:itemID="{836ABDF2-BD05-4010-80BA-3DB41DBF8678}">
+  <ds:schemaRefs>
+    <ds:schemaRef ds:uri="http://schemas.microsoft.com/office/2006/metadata/properties"/>
+    <ds:schemaRef ds:uri="http://schemas.microsoft.com/office/infopath/2007/PartnerControls"/>
+    <ds:schemaRef ds:uri="7a4191d5-9b76-4ae3-8401-87ceee92a846"/>
+    <ds:schemaRef ds:uri="b9b0194d-1e98-4efc-bad5-9450f4bf7a13"/>
+  </ds:schemaRefs>
+</ds:datastoreItem>
+</file>
+
+<file path=customXml/itemProps2.xml><?xml version="1.0" encoding="utf-8"?>
 <ds:datastoreItem xmlns:ds="http://schemas.openxmlformats.org/officeDocument/2006/customXml" ds:itemID="{88FE4E6F-A4E5-40F2-8CE2-36663D7A069E}">
   <ds:schemaRefs>
     <ds:schemaRef ds:uri="http://schemas.microsoft.com/office/2006/metadata/contentType"/>
@@ -8448,17 +8648,6 @@
 </ds:datastoreItem>
 </file>
 
-<file path=customXml/itemProps2.xml><?xml version="1.0" encoding="utf-8"?>
-<ds:datastoreItem xmlns:ds="http://schemas.openxmlformats.org/officeDocument/2006/customXml" ds:itemID="{836ABDF2-BD05-4010-80BA-3DB41DBF8678}">
-  <ds:schemaRefs>
-    <ds:schemaRef ds:uri="http://schemas.microsoft.com/office/2006/metadata/properties"/>
-    <ds:schemaRef ds:uri="http://schemas.microsoft.com/office/infopath/2007/PartnerControls"/>
-    <ds:schemaRef ds:uri="7a4191d5-9b76-4ae3-8401-87ceee92a846"/>
-    <ds:schemaRef ds:uri="b9b0194d-1e98-4efc-bad5-9450f4bf7a13"/>
-  </ds:schemaRefs>
-</ds:datastoreItem>
-</file>
-
 <file path=customXml/itemProps3.xml><?xml version="1.0" encoding="utf-8"?>
 <ds:datastoreItem xmlns:ds="http://schemas.openxmlformats.org/officeDocument/2006/customXml" ds:itemID="{B1379BBF-6672-4ABD-B16E-D222A38B6B94}">
   <ds:schemaRefs>

</xml_diff>

<commit_message>
Presentation update upto temperature data
</commit_message>
<xml_diff>
--- a/DATA604/Project/Team Energy Video Presentation.pptx
+++ b/DATA604/Project/Team Energy Video Presentation.pptx
@@ -5,7 +5,7 @@
     <p:sldMasterId id="2147483648" r:id="rId4"/>
   </p:sldMasterIdLst>
   <p:notesMasterIdLst>
-    <p:notesMasterId r:id="rId14"/>
+    <p:notesMasterId r:id="rId17"/>
   </p:notesMasterIdLst>
   <p:sldIdLst>
     <p:sldId id="256" r:id="rId5"/>
@@ -17,6 +17,9 @@
     <p:sldId id="262" r:id="rId11"/>
     <p:sldId id="263" r:id="rId12"/>
     <p:sldId id="264" r:id="rId13"/>
+    <p:sldId id="265" r:id="rId14"/>
+    <p:sldId id="266" r:id="rId15"/>
+    <p:sldId id="267" r:id="rId16"/>
   </p:sldIdLst>
   <p:sldSz cx="12192000" cy="6858000"/>
   <p:notesSz cx="6858000" cy="9144000"/>
@@ -137,7 +140,7 @@
 <file path=ppt/revisionInfo.xml><?xml version="1.0" encoding="utf-8"?>
 <p1510:revInfo xmlns:a="http://schemas.openxmlformats.org/drawingml/2006/main" xmlns:r="http://schemas.openxmlformats.org/officeDocument/2006/relationships" xmlns:p1510="http://schemas.microsoft.com/office/powerpoint/2015/10/main">
   <p1510:revLst>
-    <p1510:client id="{867D6758-E00D-441F-8B1D-675252661ABA}" v="20" dt="2025-03-26T01:23:53.769"/>
+    <p1510:client id="{867D6758-E00D-441F-8B1D-675252661ABA}" v="23" dt="2025-03-26T16:38:56.085"/>
   </p1510:revLst>
 </p1510:revInfo>
 </file>
@@ -146,8 +149,8 @@
 <pc:chgInfo xmlns:a="http://schemas.openxmlformats.org/drawingml/2006/main" xmlns:r="http://schemas.openxmlformats.org/officeDocument/2006/relationships" xmlns:ac="http://schemas.microsoft.com/office/drawing/2013/main/command" xmlns:pc="http://schemas.microsoft.com/office/powerpoint/2013/main/command">
   <pc:docChgLst>
     <pc:chgData name="Gautham Nagaraj" userId="42582a7dfd2e08c3" providerId="LiveId" clId="{867D6758-E00D-441F-8B1D-675252661ABA}"/>
-    <pc:docChg chg="undo custSel modSld">
-      <pc:chgData name="Gautham Nagaraj" userId="42582a7dfd2e08c3" providerId="LiveId" clId="{867D6758-E00D-441F-8B1D-675252661ABA}" dt="2025-03-26T01:23:53.769" v="324" actId="20577"/>
+    <pc:docChg chg="undo redo custSel addSld modSld">
+      <pc:chgData name="Gautham Nagaraj" userId="42582a7dfd2e08c3" providerId="LiveId" clId="{867D6758-E00D-441F-8B1D-675252661ABA}" dt="2025-03-26T17:44:04.622" v="1769" actId="14100"/>
       <pc:docMkLst>
         <pc:docMk/>
       </pc:docMkLst>
@@ -311,6 +314,107 @@
             <pc:docMk/>
             <pc:sldMk cId="1620598711" sldId="264"/>
             <ac:picMk id="8" creationId="{FD19E575-71D7-1B08-1ADC-D9FE148681B8}"/>
+          </ac:picMkLst>
+        </pc:picChg>
+      </pc:sldChg>
+      <pc:sldChg chg="addSp delSp modSp new mod">
+        <pc:chgData name="Gautham Nagaraj" userId="42582a7dfd2e08c3" providerId="LiveId" clId="{867D6758-E00D-441F-8B1D-675252661ABA}" dt="2025-03-26T16:39:45.855" v="544" actId="108"/>
+        <pc:sldMkLst>
+          <pc:docMk/>
+          <pc:sldMk cId="603196543" sldId="265"/>
+        </pc:sldMkLst>
+        <pc:spChg chg="del mod">
+          <ac:chgData name="Gautham Nagaraj" userId="42582a7dfd2e08c3" providerId="LiveId" clId="{867D6758-E00D-441F-8B1D-675252661ABA}" dt="2025-03-26T16:30:44.378" v="493" actId="21"/>
+          <ac:spMkLst>
+            <pc:docMk/>
+            <pc:sldMk cId="603196543" sldId="265"/>
+            <ac:spMk id="2" creationId="{32D25D08-50BC-3638-EA28-40CF58AADFCC}"/>
+          </ac:spMkLst>
+        </pc:spChg>
+        <pc:spChg chg="add del mod">
+          <ac:chgData name="Gautham Nagaraj" userId="42582a7dfd2e08c3" providerId="LiveId" clId="{867D6758-E00D-441F-8B1D-675252661ABA}" dt="2025-03-26T16:39:45.855" v="544" actId="108"/>
+          <ac:spMkLst>
+            <pc:docMk/>
+            <pc:sldMk cId="603196543" sldId="265"/>
+            <ac:spMk id="3" creationId="{09503498-1340-255C-B3C9-19742479EF9B}"/>
+          </ac:spMkLst>
+        </pc:spChg>
+        <pc:spChg chg="add mod">
+          <ac:chgData name="Gautham Nagaraj" userId="42582a7dfd2e08c3" providerId="LiveId" clId="{867D6758-E00D-441F-8B1D-675252661ABA}" dt="2025-03-26T16:30:56.056" v="497"/>
+          <ac:spMkLst>
+            <pc:docMk/>
+            <pc:sldMk cId="603196543" sldId="265"/>
+            <ac:spMk id="7" creationId="{32D25D08-50BC-3638-EA28-40CF58AADFCC}"/>
+          </ac:spMkLst>
+        </pc:spChg>
+        <pc:picChg chg="add mod">
+          <ac:chgData name="Gautham Nagaraj" userId="42582a7dfd2e08c3" providerId="LiveId" clId="{867D6758-E00D-441F-8B1D-675252661ABA}" dt="2025-03-26T16:39:07.752" v="537" actId="14100"/>
+          <ac:picMkLst>
+            <pc:docMk/>
+            <pc:sldMk cId="603196543" sldId="265"/>
+            <ac:picMk id="6" creationId="{D1680F38-D46A-FEA0-B201-7B4A9A96AA8A}"/>
+          </ac:picMkLst>
+        </pc:picChg>
+        <pc:picChg chg="add mod">
+          <ac:chgData name="Gautham Nagaraj" userId="42582a7dfd2e08c3" providerId="LiveId" clId="{867D6758-E00D-441F-8B1D-675252661ABA}" dt="2025-03-26T16:39:00.733" v="535" actId="1076"/>
+          <ac:picMkLst>
+            <pc:docMk/>
+            <pc:sldMk cId="603196543" sldId="265"/>
+            <ac:picMk id="9" creationId="{293CE496-BD9C-6588-16F9-8C526110B8DD}"/>
+          </ac:picMkLst>
+        </pc:picChg>
+      </pc:sldChg>
+      <pc:sldChg chg="modSp new mod">
+        <pc:chgData name="Gautham Nagaraj" userId="42582a7dfd2e08c3" providerId="LiveId" clId="{867D6758-E00D-441F-8B1D-675252661ABA}" dt="2025-03-26T17:38:54.094" v="1366" actId="20577"/>
+        <pc:sldMkLst>
+          <pc:docMk/>
+          <pc:sldMk cId="3008990893" sldId="266"/>
+        </pc:sldMkLst>
+        <pc:spChg chg="mod">
+          <ac:chgData name="Gautham Nagaraj" userId="42582a7dfd2e08c3" providerId="LiveId" clId="{867D6758-E00D-441F-8B1D-675252661ABA}" dt="2025-03-26T17:21:57.986" v="587" actId="20577"/>
+          <ac:spMkLst>
+            <pc:docMk/>
+            <pc:sldMk cId="3008990893" sldId="266"/>
+            <ac:spMk id="2" creationId="{2086750A-DAA9-5989-0F16-EF0A1E7D314E}"/>
+          </ac:spMkLst>
+        </pc:spChg>
+        <pc:spChg chg="mod">
+          <ac:chgData name="Gautham Nagaraj" userId="42582a7dfd2e08c3" providerId="LiveId" clId="{867D6758-E00D-441F-8B1D-675252661ABA}" dt="2025-03-26T17:38:54.094" v="1366" actId="20577"/>
+          <ac:spMkLst>
+            <pc:docMk/>
+            <pc:sldMk cId="3008990893" sldId="266"/>
+            <ac:spMk id="3" creationId="{C50EB759-C44B-42FC-9EEE-77CADB8D8033}"/>
+          </ac:spMkLst>
+        </pc:spChg>
+      </pc:sldChg>
+      <pc:sldChg chg="addSp delSp modSp new mod">
+        <pc:chgData name="Gautham Nagaraj" userId="42582a7dfd2e08c3" providerId="LiveId" clId="{867D6758-E00D-441F-8B1D-675252661ABA}" dt="2025-03-26T17:44:04.622" v="1769" actId="14100"/>
+        <pc:sldMkLst>
+          <pc:docMk/>
+          <pc:sldMk cId="2670562210" sldId="267"/>
+        </pc:sldMkLst>
+        <pc:spChg chg="del">
+          <ac:chgData name="Gautham Nagaraj" userId="42582a7dfd2e08c3" providerId="LiveId" clId="{867D6758-E00D-441F-8B1D-675252661ABA}" dt="2025-03-26T17:39:03.868" v="1368" actId="21"/>
+          <ac:spMkLst>
+            <pc:docMk/>
+            <pc:sldMk cId="2670562210" sldId="267"/>
+            <ac:spMk id="2" creationId="{E066258C-50B3-46F0-0831-C112BE7F590E}"/>
+          </ac:spMkLst>
+        </pc:spChg>
+        <pc:spChg chg="mod">
+          <ac:chgData name="Gautham Nagaraj" userId="42582a7dfd2e08c3" providerId="LiveId" clId="{867D6758-E00D-441F-8B1D-675252661ABA}" dt="2025-03-26T17:43:28.623" v="1762" actId="20577"/>
+          <ac:spMkLst>
+            <pc:docMk/>
+            <pc:sldMk cId="2670562210" sldId="267"/>
+            <ac:spMk id="3" creationId="{D36ED97D-0292-F4F4-E3BC-94BFD57979DF}"/>
+          </ac:spMkLst>
+        </pc:spChg>
+        <pc:picChg chg="add mod">
+          <ac:chgData name="Gautham Nagaraj" userId="42582a7dfd2e08c3" providerId="LiveId" clId="{867D6758-E00D-441F-8B1D-675252661ABA}" dt="2025-03-26T17:44:04.622" v="1769" actId="14100"/>
+          <ac:picMkLst>
+            <pc:docMk/>
+            <pc:sldMk cId="2670562210" sldId="267"/>
+            <ac:picMk id="6" creationId="{1B4E3A50-80E6-6BF5-4E1B-0B5301EA9F8C}"/>
           </ac:picMkLst>
         </pc:picChg>
       </pc:sldChg>
@@ -3502,7 +3606,7 @@
           <a:p>
             <a:fld id="{4B2CACE1-0839-DD4E-8A8D-815B08AED9A4}" type="datetimeFigureOut">
               <a:rPr lang="en-US" smtClean="0"/>
-              <a:t>3/25/2025</a:t>
+              <a:t>3/26/2025</a:t>
             </a:fld>
             <a:endParaRPr lang="en-US"/>
           </a:p>
@@ -6063,6 +6167,604 @@
     <p:extLst>
       <p:ext uri="{BB962C8B-B14F-4D97-AF65-F5344CB8AC3E}">
         <p14:creationId xmlns:p14="http://schemas.microsoft.com/office/powerpoint/2010/main" val="3682412263"/>
+      </p:ext>
+    </p:extLst>
+  </p:cSld>
+  <p:clrMapOvr>
+    <a:masterClrMapping/>
+  </p:clrMapOvr>
+</p:sld>
+</file>
+
+<file path=ppt/slides/slide10.xml><?xml version="1.0" encoding="utf-8"?>
+<p:sld xmlns:a="http://schemas.openxmlformats.org/drawingml/2006/main" xmlns:r="http://schemas.openxmlformats.org/officeDocument/2006/relationships" xmlns:p="http://schemas.openxmlformats.org/presentationml/2006/main">
+  <p:cSld>
+    <p:spTree>
+      <p:nvGrpSpPr>
+        <p:cNvPr id="1" name=""/>
+        <p:cNvGrpSpPr/>
+        <p:nvPr/>
+      </p:nvGrpSpPr>
+      <p:grpSpPr>
+        <a:xfrm>
+          <a:off x="0" y="0"/>
+          <a:ext cx="0" cy="0"/>
+          <a:chOff x="0" y="0"/>
+          <a:chExt cx="0" cy="0"/>
+        </a:xfrm>
+      </p:grpSpPr>
+      <p:sp>
+        <p:nvSpPr>
+          <p:cNvPr id="3" name="Content Placeholder 2">
+            <a:extLst>
+              <a:ext uri="{FF2B5EF4-FFF2-40B4-BE49-F238E27FC236}">
+                <a16:creationId xmlns:a16="http://schemas.microsoft.com/office/drawing/2014/main" id="{09503498-1340-255C-B3C9-19742479EF9B}"/>
+              </a:ext>
+            </a:extLst>
+          </p:cNvPr>
+          <p:cNvSpPr>
+            <a:spLocks noGrp="1"/>
+          </p:cNvSpPr>
+          <p:nvPr>
+            <p:ph idx="1"/>
+          </p:nvPr>
+        </p:nvSpPr>
+        <p:spPr>
+          <a:xfrm>
+            <a:off x="496110" y="301557"/>
+            <a:ext cx="5599889" cy="6313252"/>
+          </a:xfrm>
+        </p:spPr>
+        <p:txBody>
+          <a:bodyPr/>
+          <a:lstStyle/>
+          <a:p>
+            <a:pPr marL="0" indent="0">
+              <a:buNone/>
+            </a:pPr>
+            <a:r>
+              <a:rPr lang="en-US" dirty="0">
+                <a:solidFill>
+                  <a:schemeClr val="accent1">
+                    <a:lumMod val="75000"/>
+                  </a:schemeClr>
+                </a:solidFill>
+              </a:rPr>
+              <a:t>5. </a:t>
+            </a:r>
+            <a:r>
+              <a:rPr lang="en-US" sz="2400" b="0" kern="1200" dirty="0">
+                <a:solidFill>
+                  <a:srgbClr val="000000"/>
+                </a:solidFill>
+                <a:effectLst/>
+                <a:latin typeface="Calibri" panose="020F0502020204030204" pitchFamily="34" charset="0"/>
+                <a:ea typeface="+mj-ea"/>
+                <a:cs typeface="+mj-cs"/>
+              </a:rPr>
+              <a:t>Population</a:t>
+            </a:r>
+            <a:r>
+              <a:rPr lang="en-US" sz="2400" b="0" kern="1200" dirty="0">
+                <a:solidFill>
+                  <a:srgbClr val="C21110"/>
+                </a:solidFill>
+                <a:effectLst/>
+                <a:latin typeface="Calibri" panose="020F0502020204030204" pitchFamily="34" charset="0"/>
+                <a:ea typeface="+mj-ea"/>
+                <a:cs typeface="+mj-cs"/>
+              </a:rPr>
+              <a:t> </a:t>
+            </a:r>
+            <a:r>
+              <a:rPr lang="en-US" sz="2400" b="0" kern="1200" dirty="0">
+                <a:solidFill>
+                  <a:srgbClr val="000000"/>
+                </a:solidFill>
+                <a:effectLst/>
+                <a:latin typeface="Calibri" panose="020F0502020204030204" pitchFamily="34" charset="0"/>
+                <a:ea typeface="+mj-ea"/>
+                <a:cs typeface="+mj-cs"/>
+              </a:rPr>
+              <a:t>-</a:t>
+            </a:r>
+            <a:r>
+              <a:rPr lang="en-US" sz="2400" b="0" kern="1200" dirty="0">
+                <a:solidFill>
+                  <a:srgbClr val="C21110"/>
+                </a:solidFill>
+                <a:effectLst/>
+                <a:latin typeface="Calibri" panose="020F0502020204030204" pitchFamily="34" charset="0"/>
+                <a:ea typeface="+mj-ea"/>
+                <a:cs typeface="+mj-cs"/>
+              </a:rPr>
+              <a:t> </a:t>
+            </a:r>
+            <a:r>
+              <a:rPr lang="en-US" sz="2400" b="0" kern="1200" dirty="0">
+                <a:solidFill>
+                  <a:srgbClr val="000000"/>
+                </a:solidFill>
+                <a:effectLst/>
+                <a:latin typeface="Calibri" panose="020F0502020204030204" pitchFamily="34" charset="0"/>
+                <a:ea typeface="+mj-ea"/>
+                <a:cs typeface="+mj-cs"/>
+              </a:rPr>
+              <a:t>The population will play a</a:t>
+            </a:r>
+            <a:br>
+              <a:rPr lang="en-US" sz="2400" b="0" kern="1200" dirty="0">
+                <a:solidFill>
+                  <a:srgbClr val="000000"/>
+                </a:solidFill>
+                <a:effectLst/>
+                <a:latin typeface="Calibri" panose="020F0502020204030204" pitchFamily="34" charset="0"/>
+                <a:ea typeface="+mj-ea"/>
+                <a:cs typeface="+mj-cs"/>
+              </a:rPr>
+            </a:br>
+            <a:r>
+              <a:rPr lang="en-US" sz="2400" b="0" kern="1200" dirty="0">
+                <a:solidFill>
+                  <a:srgbClr val="000000"/>
+                </a:solidFill>
+                <a:effectLst/>
+                <a:latin typeface="Calibri" panose="020F0502020204030204" pitchFamily="34" charset="0"/>
+                <a:ea typeface="+mj-ea"/>
+                <a:cs typeface="+mj-cs"/>
+              </a:rPr>
+              <a:t> huge role in demand, which in turn </a:t>
+            </a:r>
+            <a:br>
+              <a:rPr lang="en-US" sz="2400" b="0" kern="1200" dirty="0">
+                <a:solidFill>
+                  <a:srgbClr val="000000"/>
+                </a:solidFill>
+                <a:effectLst/>
+                <a:latin typeface="Calibri" panose="020F0502020204030204" pitchFamily="34" charset="0"/>
+                <a:ea typeface="+mj-ea"/>
+                <a:cs typeface="+mj-cs"/>
+              </a:rPr>
+            </a:br>
+            <a:r>
+              <a:rPr lang="en-US" sz="2400" b="0" kern="1200" dirty="0">
+                <a:solidFill>
+                  <a:srgbClr val="000000"/>
+                </a:solidFill>
+                <a:effectLst/>
+                <a:latin typeface="Calibri" panose="020F0502020204030204" pitchFamily="34" charset="0"/>
+                <a:ea typeface="+mj-ea"/>
+                <a:cs typeface="+mj-cs"/>
+              </a:rPr>
+              <a:t>will play a factor in determining the price</a:t>
+            </a:r>
+          </a:p>
+          <a:p>
+            <a:r>
+              <a:rPr lang="en-US" sz="2400" b="0" kern="1200" dirty="0">
+                <a:solidFill>
+                  <a:srgbClr val="000000"/>
+                </a:solidFill>
+                <a:effectLst/>
+                <a:latin typeface="Calibri" panose="020F0502020204030204" pitchFamily="34" charset="0"/>
+                <a:ea typeface="+mj-ea"/>
+                <a:cs typeface="+mj-cs"/>
+              </a:rPr>
+              <a:t>Alberta has experienced a relatively high rate of growth in recent years, due in large part to its economy</a:t>
+            </a:r>
+          </a:p>
+          <a:p>
+            <a:r>
+              <a:rPr lang="en-US" sz="2400" dirty="0">
+                <a:solidFill>
+                  <a:srgbClr val="000000"/>
+                </a:solidFill>
+                <a:latin typeface="Calibri" panose="020F0502020204030204" pitchFamily="34" charset="0"/>
+                <a:ea typeface="+mj-ea"/>
+                <a:cs typeface="+mj-cs"/>
+              </a:rPr>
+              <a:t>R</a:t>
+            </a:r>
+            <a:r>
+              <a:rPr lang="en-US" sz="2400" b="0" kern="1200" dirty="0">
+                <a:solidFill>
+                  <a:srgbClr val="000000"/>
+                </a:solidFill>
+                <a:effectLst/>
+                <a:latin typeface="Calibri" panose="020F0502020204030204" pitchFamily="34" charset="0"/>
+                <a:ea typeface="+mj-ea"/>
+                <a:cs typeface="+mj-cs"/>
+              </a:rPr>
+              <a:t>elatively high immigration, and a high rate of interprovincial migration when compared to other provinces.</a:t>
+            </a:r>
+          </a:p>
+          <a:p>
+            <a:r>
+              <a:rPr lang="en-US" sz="2400" dirty="0"/>
+              <a:t>Over the past five decades, Alberta has had the highest net increase from interprovincial migration of any province.</a:t>
+            </a:r>
+          </a:p>
+          <a:p>
+            <a:r>
+              <a:rPr lang="en-US" sz="2400" dirty="0"/>
+              <a:t>Interprovincial migration to Alberta rises and drops dependent of the price of oil.</a:t>
+            </a:r>
+            <a:endParaRPr lang="en-IN" sz="2400" dirty="0"/>
+          </a:p>
+        </p:txBody>
+      </p:sp>
+      <p:sp>
+        <p:nvSpPr>
+          <p:cNvPr id="4" name="Slide Number Placeholder 3">
+            <a:extLst>
+              <a:ext uri="{FF2B5EF4-FFF2-40B4-BE49-F238E27FC236}">
+                <a16:creationId xmlns:a16="http://schemas.microsoft.com/office/drawing/2014/main" id="{D323AB32-C324-DE30-A84C-79D1511E369C}"/>
+              </a:ext>
+            </a:extLst>
+          </p:cNvPr>
+          <p:cNvSpPr>
+            <a:spLocks noGrp="1"/>
+          </p:cNvSpPr>
+          <p:nvPr>
+            <p:ph type="sldNum" sz="quarter" idx="12"/>
+          </p:nvPr>
+        </p:nvSpPr>
+        <p:spPr/>
+        <p:txBody>
+          <a:bodyPr/>
+          <a:lstStyle/>
+          <a:p>
+            <a:fld id="{5C35FCF4-C3EF-BD43-82E0-05BC237DAD2A}" type="slidenum">
+              <a:rPr lang="en-US" smtClean="0"/>
+              <a:pPr/>
+              <a:t>10</a:t>
+            </a:fld>
+            <a:endParaRPr lang="en-US" dirty="0"/>
+          </a:p>
+        </p:txBody>
+      </p:sp>
+      <p:pic>
+        <p:nvPicPr>
+          <p:cNvPr id="6" name="Picture 5">
+            <a:extLst>
+              <a:ext uri="{FF2B5EF4-FFF2-40B4-BE49-F238E27FC236}">
+                <a16:creationId xmlns:a16="http://schemas.microsoft.com/office/drawing/2014/main" id="{D1680F38-D46A-FEA0-B201-7B4A9A96AA8A}"/>
+              </a:ext>
+            </a:extLst>
+          </p:cNvPr>
+          <p:cNvPicPr>
+            <a:picLocks noChangeAspect="1"/>
+          </p:cNvPicPr>
+          <p:nvPr/>
+        </p:nvPicPr>
+        <p:blipFill>
+          <a:blip r:embed="rId2"/>
+          <a:stretch>
+            <a:fillRect/>
+          </a:stretch>
+        </p:blipFill>
+        <p:spPr>
+          <a:xfrm>
+            <a:off x="5952569" y="982494"/>
+            <a:ext cx="4436049" cy="2898842"/>
+          </a:xfrm>
+          <a:prstGeom prst="rect">
+            <a:avLst/>
+          </a:prstGeom>
+        </p:spPr>
+      </p:pic>
+      <p:pic>
+        <p:nvPicPr>
+          <p:cNvPr id="9" name="Graphic 8" descr="Group of people with solid fill">
+            <a:extLst>
+              <a:ext uri="{FF2B5EF4-FFF2-40B4-BE49-F238E27FC236}">
+                <a16:creationId xmlns:a16="http://schemas.microsoft.com/office/drawing/2014/main" id="{293CE496-BD9C-6588-16F9-8C526110B8DD}"/>
+              </a:ext>
+            </a:extLst>
+          </p:cNvPr>
+          <p:cNvPicPr>
+            <a:picLocks noChangeAspect="1"/>
+          </p:cNvPicPr>
+          <p:nvPr/>
+        </p:nvPicPr>
+        <p:blipFill>
+          <a:blip r:embed="rId3">
+            <a:extLst>
+              <a:ext uri="{96DAC541-7B7A-43D3-8B79-37D633B846F1}">
+                <asvg:svgBlip xmlns:asvg="http://schemas.microsoft.com/office/drawing/2016/SVG/main" r:embed="rId4"/>
+              </a:ext>
+            </a:extLst>
+          </a:blip>
+          <a:stretch>
+            <a:fillRect/>
+          </a:stretch>
+        </p:blipFill>
+        <p:spPr>
+          <a:xfrm>
+            <a:off x="10518027" y="1695657"/>
+            <a:ext cx="1275803" cy="1275803"/>
+          </a:xfrm>
+          <a:prstGeom prst="rect">
+            <a:avLst/>
+          </a:prstGeom>
+        </p:spPr>
+      </p:pic>
+    </p:spTree>
+    <p:extLst>
+      <p:ext uri="{BB962C8B-B14F-4D97-AF65-F5344CB8AC3E}">
+        <p14:creationId xmlns:p14="http://schemas.microsoft.com/office/powerpoint/2010/main" val="603196543"/>
+      </p:ext>
+    </p:extLst>
+  </p:cSld>
+  <p:clrMapOvr>
+    <a:masterClrMapping/>
+  </p:clrMapOvr>
+</p:sld>
+</file>
+
+<file path=ppt/slides/slide11.xml><?xml version="1.0" encoding="utf-8"?>
+<p:sld xmlns:a="http://schemas.openxmlformats.org/drawingml/2006/main" xmlns:r="http://schemas.openxmlformats.org/officeDocument/2006/relationships" xmlns:p="http://schemas.openxmlformats.org/presentationml/2006/main">
+  <p:cSld>
+    <p:spTree>
+      <p:nvGrpSpPr>
+        <p:cNvPr id="1" name=""/>
+        <p:cNvGrpSpPr/>
+        <p:nvPr/>
+      </p:nvGrpSpPr>
+      <p:grpSpPr>
+        <a:xfrm>
+          <a:off x="0" y="0"/>
+          <a:ext cx="0" cy="0"/>
+          <a:chOff x="0" y="0"/>
+          <a:chExt cx="0" cy="0"/>
+        </a:xfrm>
+      </p:grpSpPr>
+      <p:sp>
+        <p:nvSpPr>
+          <p:cNvPr id="2" name="Title 1">
+            <a:extLst>
+              <a:ext uri="{FF2B5EF4-FFF2-40B4-BE49-F238E27FC236}">
+                <a16:creationId xmlns:a16="http://schemas.microsoft.com/office/drawing/2014/main" id="{2086750A-DAA9-5989-0F16-EF0A1E7D314E}"/>
+              </a:ext>
+            </a:extLst>
+          </p:cNvPr>
+          <p:cNvSpPr>
+            <a:spLocks noGrp="1"/>
+          </p:cNvSpPr>
+          <p:nvPr>
+            <p:ph type="title"/>
+          </p:nvPr>
+        </p:nvSpPr>
+        <p:spPr/>
+        <p:txBody>
+          <a:bodyPr/>
+          <a:lstStyle/>
+          <a:p>
+            <a:r>
+              <a:rPr lang="en-US" dirty="0"/>
+              <a:t>Insights gained from each dataset	</a:t>
+            </a:r>
+            <a:endParaRPr lang="en-IN" dirty="0"/>
+          </a:p>
+        </p:txBody>
+      </p:sp>
+      <p:sp>
+        <p:nvSpPr>
+          <p:cNvPr id="3" name="Content Placeholder 2">
+            <a:extLst>
+              <a:ext uri="{FF2B5EF4-FFF2-40B4-BE49-F238E27FC236}">
+                <a16:creationId xmlns:a16="http://schemas.microsoft.com/office/drawing/2014/main" id="{C50EB759-C44B-42FC-9EEE-77CADB8D8033}"/>
+              </a:ext>
+            </a:extLst>
+          </p:cNvPr>
+          <p:cNvSpPr>
+            <a:spLocks noGrp="1"/>
+          </p:cNvSpPr>
+          <p:nvPr>
+            <p:ph idx="1"/>
+          </p:nvPr>
+        </p:nvSpPr>
+        <p:spPr>
+          <a:xfrm>
+            <a:off x="562628" y="2140085"/>
+            <a:ext cx="9724372" cy="3748779"/>
+          </a:xfrm>
+        </p:spPr>
+        <p:txBody>
+          <a:bodyPr/>
+          <a:lstStyle/>
+          <a:p>
+            <a:r>
+              <a:rPr lang="en-US" sz="2400" dirty="0"/>
+              <a:t>Temperature data – The temperature data when joined with the generation dataset gives us some insights on what the generation value is based on the temperature</a:t>
+            </a:r>
+          </a:p>
+          <a:p>
+            <a:r>
+              <a:rPr lang="en-IN" sz="2400" dirty="0"/>
+              <a:t>We can combine 2 datasets using an inner join based on the date column</a:t>
+            </a:r>
+          </a:p>
+          <a:p>
+            <a:r>
+              <a:rPr lang="en-IN" sz="2400" dirty="0"/>
+              <a:t>Ordering the results by temperature, we can see which days have the highest electricity generated compared to the lowest temperatures</a:t>
+            </a:r>
+          </a:p>
+          <a:p>
+            <a:r>
+              <a:rPr lang="en-IN" sz="2400" dirty="0"/>
+              <a:t>We are expected to see a rise in electricity generated when the temperatures drop, however a rise in temperature also increases the electricity generated</a:t>
+            </a:r>
+          </a:p>
+        </p:txBody>
+      </p:sp>
+      <p:sp>
+        <p:nvSpPr>
+          <p:cNvPr id="4" name="Slide Number Placeholder 3">
+            <a:extLst>
+              <a:ext uri="{FF2B5EF4-FFF2-40B4-BE49-F238E27FC236}">
+                <a16:creationId xmlns:a16="http://schemas.microsoft.com/office/drawing/2014/main" id="{32E76D7A-D9D0-544A-F7AE-BBD35D106EFA}"/>
+              </a:ext>
+            </a:extLst>
+          </p:cNvPr>
+          <p:cNvSpPr>
+            <a:spLocks noGrp="1"/>
+          </p:cNvSpPr>
+          <p:nvPr>
+            <p:ph type="sldNum" sz="quarter" idx="12"/>
+          </p:nvPr>
+        </p:nvSpPr>
+        <p:spPr/>
+        <p:txBody>
+          <a:bodyPr/>
+          <a:lstStyle/>
+          <a:p>
+            <a:fld id="{5C35FCF4-C3EF-BD43-82E0-05BC237DAD2A}" type="slidenum">
+              <a:rPr lang="en-US" smtClean="0"/>
+              <a:pPr/>
+              <a:t>11</a:t>
+            </a:fld>
+            <a:endParaRPr lang="en-US" dirty="0"/>
+          </a:p>
+        </p:txBody>
+      </p:sp>
+    </p:spTree>
+    <p:extLst>
+      <p:ext uri="{BB962C8B-B14F-4D97-AF65-F5344CB8AC3E}">
+        <p14:creationId xmlns:p14="http://schemas.microsoft.com/office/powerpoint/2010/main" val="3008990893"/>
+      </p:ext>
+    </p:extLst>
+  </p:cSld>
+  <p:clrMapOvr>
+    <a:masterClrMapping/>
+  </p:clrMapOvr>
+</p:sld>
+</file>
+
+<file path=ppt/slides/slide12.xml><?xml version="1.0" encoding="utf-8"?>
+<p:sld xmlns:a="http://schemas.openxmlformats.org/drawingml/2006/main" xmlns:r="http://schemas.openxmlformats.org/officeDocument/2006/relationships" xmlns:p="http://schemas.openxmlformats.org/presentationml/2006/main">
+  <p:cSld>
+    <p:spTree>
+      <p:nvGrpSpPr>
+        <p:cNvPr id="1" name=""/>
+        <p:cNvGrpSpPr/>
+        <p:nvPr/>
+      </p:nvGrpSpPr>
+      <p:grpSpPr>
+        <a:xfrm>
+          <a:off x="0" y="0"/>
+          <a:ext cx="0" cy="0"/>
+          <a:chOff x="0" y="0"/>
+          <a:chExt cx="0" cy="0"/>
+        </a:xfrm>
+      </p:grpSpPr>
+      <p:sp>
+        <p:nvSpPr>
+          <p:cNvPr id="3" name="Content Placeholder 2">
+            <a:extLst>
+              <a:ext uri="{FF2B5EF4-FFF2-40B4-BE49-F238E27FC236}">
+                <a16:creationId xmlns:a16="http://schemas.microsoft.com/office/drawing/2014/main" id="{D36ED97D-0292-F4F4-E3BC-94BFD57979DF}"/>
+              </a:ext>
+            </a:extLst>
+          </p:cNvPr>
+          <p:cNvSpPr>
+            <a:spLocks noGrp="1"/>
+          </p:cNvSpPr>
+          <p:nvPr>
+            <p:ph idx="1"/>
+          </p:nvPr>
+        </p:nvSpPr>
+        <p:spPr>
+          <a:xfrm>
+            <a:off x="562628" y="466929"/>
+            <a:ext cx="9724372" cy="5421936"/>
+          </a:xfrm>
+        </p:spPr>
+        <p:txBody>
+          <a:bodyPr/>
+          <a:lstStyle/>
+          <a:p>
+            <a:r>
+              <a:rPr lang="en-US" dirty="0"/>
+              <a:t>This indicates that the relationship is not linear </a:t>
+            </a:r>
+          </a:p>
+          <a:p>
+            <a:r>
+              <a:rPr lang="en-IN" dirty="0"/>
+              <a:t>If we were to build a regression model, we would need to look at non-linear models or exclude the temperature variable due to non-linearity</a:t>
+            </a:r>
+          </a:p>
+          <a:p>
+            <a:endParaRPr lang="en-US" dirty="0"/>
+          </a:p>
+        </p:txBody>
+      </p:sp>
+      <p:sp>
+        <p:nvSpPr>
+          <p:cNvPr id="4" name="Slide Number Placeholder 3">
+            <a:extLst>
+              <a:ext uri="{FF2B5EF4-FFF2-40B4-BE49-F238E27FC236}">
+                <a16:creationId xmlns:a16="http://schemas.microsoft.com/office/drawing/2014/main" id="{26A05CBE-BD42-D6AA-7874-9420A4C766AC}"/>
+              </a:ext>
+            </a:extLst>
+          </p:cNvPr>
+          <p:cNvSpPr>
+            <a:spLocks noGrp="1"/>
+          </p:cNvSpPr>
+          <p:nvPr>
+            <p:ph type="sldNum" sz="quarter" idx="12"/>
+          </p:nvPr>
+        </p:nvSpPr>
+        <p:spPr/>
+        <p:txBody>
+          <a:bodyPr/>
+          <a:lstStyle/>
+          <a:p>
+            <a:fld id="{5C35FCF4-C3EF-BD43-82E0-05BC237DAD2A}" type="slidenum">
+              <a:rPr lang="en-US" smtClean="0"/>
+              <a:pPr/>
+              <a:t>12</a:t>
+            </a:fld>
+            <a:endParaRPr lang="en-US" dirty="0"/>
+          </a:p>
+        </p:txBody>
+      </p:sp>
+      <p:pic>
+        <p:nvPicPr>
+          <p:cNvPr id="6" name="Picture 5">
+            <a:extLst>
+              <a:ext uri="{FF2B5EF4-FFF2-40B4-BE49-F238E27FC236}">
+                <a16:creationId xmlns:a16="http://schemas.microsoft.com/office/drawing/2014/main" id="{1B4E3A50-80E6-6BF5-4E1B-0B5301EA9F8C}"/>
+              </a:ext>
+            </a:extLst>
+          </p:cNvPr>
+          <p:cNvPicPr>
+            <a:picLocks noChangeAspect="1"/>
+          </p:cNvPicPr>
+          <p:nvPr/>
+        </p:nvPicPr>
+        <p:blipFill>
+          <a:blip r:embed="rId2"/>
+          <a:stretch>
+            <a:fillRect/>
+          </a:stretch>
+        </p:blipFill>
+        <p:spPr>
+          <a:xfrm>
+            <a:off x="1070043" y="2269631"/>
+            <a:ext cx="8570067" cy="4588369"/>
+          </a:xfrm>
+          <a:prstGeom prst="rect">
+            <a:avLst/>
+          </a:prstGeom>
+        </p:spPr>
+      </p:pic>
+    </p:spTree>
+    <p:extLst>
+      <p:ext uri="{BB962C8B-B14F-4D97-AF65-F5344CB8AC3E}">
+        <p14:creationId xmlns:p14="http://schemas.microsoft.com/office/powerpoint/2010/main" val="2670562210"/>
       </p:ext>
     </p:extLst>
   </p:cSld>
@@ -8364,29 +9066,6 @@
 </file>
 
 <file path=customXml/item1.xml><?xml version="1.0" encoding="utf-8"?>
-<p:properties xmlns:p="http://schemas.microsoft.com/office/2006/metadata/properties" xmlns:xsi="http://www.w3.org/2001/XMLSchema-instance" xmlns:pc="http://schemas.microsoft.com/office/infopath/2007/PartnerControls">
-  <documentManagement>
-    <SharedWithUsers xmlns="7a4191d5-9b76-4ae3-8401-87ceee92a846">
-      <UserInfo>
-        <DisplayName>Office Of Advancement Visitors</DisplayName>
-        <AccountId>4</AccountId>
-        <AccountType/>
-      </UserInfo>
-      <UserInfo>
-        <DisplayName>UCalgary Brand</DisplayName>
-        <AccountId>15</AccountId>
-        <AccountType/>
-      </UserInfo>
-    </SharedWithUsers>
-    <TaxCatchAll xmlns="7a4191d5-9b76-4ae3-8401-87ceee92a846" xsi:nil="true"/>
-    <lcf76f155ced4ddcb4097134ff3c332f xmlns="b9b0194d-1e98-4efc-bad5-9450f4bf7a13">
-      <Terms xmlns="http://schemas.microsoft.com/office/infopath/2007/PartnerControls"/>
-    </lcf76f155ced4ddcb4097134ff3c332f>
-  </documentManagement>
-</p:properties>
-</file>
-
-<file path=customXml/item2.xml><?xml version="1.0" encoding="utf-8"?>
 <ct:contentTypeSchema xmlns:ct="http://schemas.microsoft.com/office/2006/metadata/contentType" xmlns:ma="http://schemas.microsoft.com/office/2006/metadata/properties/metaAttributes" ct:_="" ma:_="" ma:contentTypeName="Document" ma:contentTypeID="0x010100A14D9A0FA515564792FEACC70AB1043E" ma:contentTypeVersion="15" ma:contentTypeDescription="Create a new document." ma:contentTypeScope="" ma:versionID="3387522b3212352fc6bbea455d3cfc53">
   <xsd:schema xmlns:xsd="http://www.w3.org/2001/XMLSchema" xmlns:xs="http://www.w3.org/2001/XMLSchema" xmlns:p="http://schemas.microsoft.com/office/2006/metadata/properties" xmlns:ns2="7a4191d5-9b76-4ae3-8401-87ceee92a846" xmlns:ns3="b9b0194d-1e98-4efc-bad5-9450f4bf7a13" targetNamespace="http://schemas.microsoft.com/office/2006/metadata/properties" ma:root="true" ma:fieldsID="e28e2b4de73025e43726d49ef756c6aa" ns2:_="" ns3:_="">
     <xsd:import namespace="7a4191d5-9b76-4ae3-8401-87ceee92a846"/>
@@ -8609,6 +9288,29 @@
 </ct:contentTypeSchema>
 </file>
 
+<file path=customXml/item2.xml><?xml version="1.0" encoding="utf-8"?>
+<p:properties xmlns:p="http://schemas.microsoft.com/office/2006/metadata/properties" xmlns:xsi="http://www.w3.org/2001/XMLSchema-instance" xmlns:pc="http://schemas.microsoft.com/office/infopath/2007/PartnerControls">
+  <documentManagement>
+    <SharedWithUsers xmlns="7a4191d5-9b76-4ae3-8401-87ceee92a846">
+      <UserInfo>
+        <DisplayName>Office Of Advancement Visitors</DisplayName>
+        <AccountId>4</AccountId>
+        <AccountType/>
+      </UserInfo>
+      <UserInfo>
+        <DisplayName>UCalgary Brand</DisplayName>
+        <AccountId>15</AccountId>
+        <AccountType/>
+      </UserInfo>
+    </SharedWithUsers>
+    <TaxCatchAll xmlns="7a4191d5-9b76-4ae3-8401-87ceee92a846" xsi:nil="true"/>
+    <lcf76f155ced4ddcb4097134ff3c332f xmlns="b9b0194d-1e98-4efc-bad5-9450f4bf7a13">
+      <Terms xmlns="http://schemas.microsoft.com/office/infopath/2007/PartnerControls"/>
+    </lcf76f155ced4ddcb4097134ff3c332f>
+  </documentManagement>
+</p:properties>
+</file>
+
 <file path=customXml/item3.xml><?xml version="1.0" encoding="utf-8"?>
 <?mso-contentType ?>
 <FormTemplates xmlns="http://schemas.microsoft.com/sharepoint/v3/contenttype/forms">
@@ -8619,17 +9321,6 @@
 </file>
 
 <file path=customXml/itemProps1.xml><?xml version="1.0" encoding="utf-8"?>
-<ds:datastoreItem xmlns:ds="http://schemas.openxmlformats.org/officeDocument/2006/customXml" ds:itemID="{836ABDF2-BD05-4010-80BA-3DB41DBF8678}">
-  <ds:schemaRefs>
-    <ds:schemaRef ds:uri="http://schemas.microsoft.com/office/2006/metadata/properties"/>
-    <ds:schemaRef ds:uri="http://schemas.microsoft.com/office/infopath/2007/PartnerControls"/>
-    <ds:schemaRef ds:uri="7a4191d5-9b76-4ae3-8401-87ceee92a846"/>
-    <ds:schemaRef ds:uri="b9b0194d-1e98-4efc-bad5-9450f4bf7a13"/>
-  </ds:schemaRefs>
-</ds:datastoreItem>
-</file>
-
-<file path=customXml/itemProps2.xml><?xml version="1.0" encoding="utf-8"?>
 <ds:datastoreItem xmlns:ds="http://schemas.openxmlformats.org/officeDocument/2006/customXml" ds:itemID="{88FE4E6F-A4E5-40F2-8CE2-36663D7A069E}">
   <ds:schemaRefs>
     <ds:schemaRef ds:uri="http://schemas.microsoft.com/office/2006/metadata/contentType"/>
@@ -8648,6 +9339,17 @@
 </ds:datastoreItem>
 </file>
 
+<file path=customXml/itemProps2.xml><?xml version="1.0" encoding="utf-8"?>
+<ds:datastoreItem xmlns:ds="http://schemas.openxmlformats.org/officeDocument/2006/customXml" ds:itemID="{836ABDF2-BD05-4010-80BA-3DB41DBF8678}">
+  <ds:schemaRefs>
+    <ds:schemaRef ds:uri="http://schemas.microsoft.com/office/2006/metadata/properties"/>
+    <ds:schemaRef ds:uri="http://schemas.microsoft.com/office/infopath/2007/PartnerControls"/>
+    <ds:schemaRef ds:uri="7a4191d5-9b76-4ae3-8401-87ceee92a846"/>
+    <ds:schemaRef ds:uri="b9b0194d-1e98-4efc-bad5-9450f4bf7a13"/>
+  </ds:schemaRefs>
+</ds:datastoreItem>
+</file>
+
 <file path=customXml/itemProps3.xml><?xml version="1.0" encoding="utf-8"?>
 <ds:datastoreItem xmlns:ds="http://schemas.openxmlformats.org/officeDocument/2006/customXml" ds:itemID="{B1379BBF-6672-4ABD-B16E-D222A38B6B94}">
   <ds:schemaRefs>

</xml_diff>

<commit_message>
Presentation slides updated upto temperature data
</commit_message>
<xml_diff>
--- a/DATA604/Project/Team Energy Video Presentation.pptx
+++ b/DATA604/Project/Team Energy Video Presentation.pptx
@@ -5,7 +5,7 @@
     <p:sldMasterId id="2147483648" r:id="rId4"/>
   </p:sldMasterIdLst>
   <p:notesMasterIdLst>
-    <p:notesMasterId r:id="rId17"/>
+    <p:notesMasterId r:id="rId18"/>
   </p:notesMasterIdLst>
   <p:sldIdLst>
     <p:sldId id="256" r:id="rId5"/>
@@ -20,6 +20,7 @@
     <p:sldId id="265" r:id="rId14"/>
     <p:sldId id="266" r:id="rId15"/>
     <p:sldId id="267" r:id="rId16"/>
+    <p:sldId id="268" r:id="rId17"/>
   </p:sldIdLst>
   <p:sldSz cx="12192000" cy="6858000"/>
   <p:notesSz cx="6858000" cy="9144000"/>
@@ -150,7 +151,7 @@
   <pc:docChgLst>
     <pc:chgData name="Gautham Nagaraj" userId="42582a7dfd2e08c3" providerId="LiveId" clId="{867D6758-E00D-441F-8B1D-675252661ABA}"/>
     <pc:docChg chg="undo redo custSel addSld modSld">
-      <pc:chgData name="Gautham Nagaraj" userId="42582a7dfd2e08c3" providerId="LiveId" clId="{867D6758-E00D-441F-8B1D-675252661ABA}" dt="2025-03-26T17:44:04.622" v="1769" actId="14100"/>
+      <pc:chgData name="Gautham Nagaraj" userId="42582a7dfd2e08c3" providerId="LiveId" clId="{867D6758-E00D-441F-8B1D-675252661ABA}" dt="2025-03-26T17:50:20.172" v="1796" actId="20577"/>
       <pc:docMkLst>
         <pc:docMk/>
       </pc:docMkLst>
@@ -417,6 +418,21 @@
             <ac:picMk id="6" creationId="{1B4E3A50-80E6-6BF5-4E1B-0B5301EA9F8C}"/>
           </ac:picMkLst>
         </pc:picChg>
+      </pc:sldChg>
+      <pc:sldChg chg="modSp new mod">
+        <pc:chgData name="Gautham Nagaraj" userId="42582a7dfd2e08c3" providerId="LiveId" clId="{867D6758-E00D-441F-8B1D-675252661ABA}" dt="2025-03-26T17:50:20.172" v="1796" actId="20577"/>
+        <pc:sldMkLst>
+          <pc:docMk/>
+          <pc:sldMk cId="530705649" sldId="268"/>
+        </pc:sldMkLst>
+        <pc:spChg chg="mod">
+          <ac:chgData name="Gautham Nagaraj" userId="42582a7dfd2e08c3" providerId="LiveId" clId="{867D6758-E00D-441F-8B1D-675252661ABA}" dt="2025-03-26T17:50:20.172" v="1796" actId="20577"/>
+          <ac:spMkLst>
+            <pc:docMk/>
+            <pc:sldMk cId="530705649" sldId="268"/>
+            <ac:spMk id="2" creationId="{BEDBEFA0-6E6B-63F6-91F2-9696E647751B}"/>
+          </ac:spMkLst>
+        </pc:spChg>
       </pc:sldChg>
     </pc:docChg>
   </pc:docChgLst>
@@ -6774,6 +6790,120 @@
 </p:sld>
 </file>
 
+<file path=ppt/slides/slide13.xml><?xml version="1.0" encoding="utf-8"?>
+<p:sld xmlns:a="http://schemas.openxmlformats.org/drawingml/2006/main" xmlns:r="http://schemas.openxmlformats.org/officeDocument/2006/relationships" xmlns:p="http://schemas.openxmlformats.org/presentationml/2006/main">
+  <p:cSld>
+    <p:spTree>
+      <p:nvGrpSpPr>
+        <p:cNvPr id="1" name=""/>
+        <p:cNvGrpSpPr/>
+        <p:nvPr/>
+      </p:nvGrpSpPr>
+      <p:grpSpPr>
+        <a:xfrm>
+          <a:off x="0" y="0"/>
+          <a:ext cx="0" cy="0"/>
+          <a:chOff x="0" y="0"/>
+          <a:chExt cx="0" cy="0"/>
+        </a:xfrm>
+      </p:grpSpPr>
+      <p:sp>
+        <p:nvSpPr>
+          <p:cNvPr id="2" name="Title 1">
+            <a:extLst>
+              <a:ext uri="{FF2B5EF4-FFF2-40B4-BE49-F238E27FC236}">
+                <a16:creationId xmlns:a16="http://schemas.microsoft.com/office/drawing/2014/main" id="{BEDBEFA0-6E6B-63F6-91F2-9696E647751B}"/>
+              </a:ext>
+            </a:extLst>
+          </p:cNvPr>
+          <p:cNvSpPr>
+            <a:spLocks noGrp="1"/>
+          </p:cNvSpPr>
+          <p:nvPr>
+            <p:ph type="title"/>
+          </p:nvPr>
+        </p:nvSpPr>
+        <p:spPr/>
+        <p:txBody>
+          <a:bodyPr/>
+          <a:lstStyle/>
+          <a:p>
+            <a:r>
+              <a:rPr lang="en-US" dirty="0"/>
+              <a:t>Add your insights here</a:t>
+            </a:r>
+            <a:endParaRPr lang="en-IN" dirty="0"/>
+          </a:p>
+        </p:txBody>
+      </p:sp>
+      <p:sp>
+        <p:nvSpPr>
+          <p:cNvPr id="3" name="Content Placeholder 2">
+            <a:extLst>
+              <a:ext uri="{FF2B5EF4-FFF2-40B4-BE49-F238E27FC236}">
+                <a16:creationId xmlns:a16="http://schemas.microsoft.com/office/drawing/2014/main" id="{90D25C09-7E16-145F-EF2C-8F490301EF4C}"/>
+              </a:ext>
+            </a:extLst>
+          </p:cNvPr>
+          <p:cNvSpPr>
+            <a:spLocks noGrp="1"/>
+          </p:cNvSpPr>
+          <p:nvPr>
+            <p:ph idx="1"/>
+          </p:nvPr>
+        </p:nvSpPr>
+        <p:spPr/>
+        <p:txBody>
+          <a:bodyPr/>
+          <a:lstStyle/>
+          <a:p>
+            <a:endParaRPr lang="en-IN"/>
+          </a:p>
+        </p:txBody>
+      </p:sp>
+      <p:sp>
+        <p:nvSpPr>
+          <p:cNvPr id="4" name="Slide Number Placeholder 3">
+            <a:extLst>
+              <a:ext uri="{FF2B5EF4-FFF2-40B4-BE49-F238E27FC236}">
+                <a16:creationId xmlns:a16="http://schemas.microsoft.com/office/drawing/2014/main" id="{68DDBACA-E5E3-1AE2-0F01-3818CFE26F58}"/>
+              </a:ext>
+            </a:extLst>
+          </p:cNvPr>
+          <p:cNvSpPr>
+            <a:spLocks noGrp="1"/>
+          </p:cNvSpPr>
+          <p:nvPr>
+            <p:ph type="sldNum" sz="quarter" idx="12"/>
+          </p:nvPr>
+        </p:nvSpPr>
+        <p:spPr/>
+        <p:txBody>
+          <a:bodyPr/>
+          <a:lstStyle/>
+          <a:p>
+            <a:fld id="{5C35FCF4-C3EF-BD43-82E0-05BC237DAD2A}" type="slidenum">
+              <a:rPr lang="en-US" smtClean="0"/>
+              <a:pPr/>
+              <a:t>13</a:t>
+            </a:fld>
+            <a:endParaRPr lang="en-US" dirty="0"/>
+          </a:p>
+        </p:txBody>
+      </p:sp>
+    </p:spTree>
+    <p:extLst>
+      <p:ext uri="{BB962C8B-B14F-4D97-AF65-F5344CB8AC3E}">
+        <p14:creationId xmlns:p14="http://schemas.microsoft.com/office/powerpoint/2010/main" val="530705649"/>
+      </p:ext>
+    </p:extLst>
+  </p:cSld>
+  <p:clrMapOvr>
+    <a:masterClrMapping/>
+  </p:clrMapOvr>
+</p:sld>
+</file>
+
 <file path=ppt/slides/slide2.xml><?xml version="1.0" encoding="utf-8"?>
 <p:sld xmlns:a="http://schemas.openxmlformats.org/drawingml/2006/main" xmlns:r="http://schemas.openxmlformats.org/officeDocument/2006/relationships" xmlns:p="http://schemas.openxmlformats.org/presentationml/2006/main">
   <p:cSld>
@@ -9066,6 +9196,29 @@
 </file>
 
 <file path=customXml/item1.xml><?xml version="1.0" encoding="utf-8"?>
+<p:properties xmlns:p="http://schemas.microsoft.com/office/2006/metadata/properties" xmlns:xsi="http://www.w3.org/2001/XMLSchema-instance" xmlns:pc="http://schemas.microsoft.com/office/infopath/2007/PartnerControls">
+  <documentManagement>
+    <SharedWithUsers xmlns="7a4191d5-9b76-4ae3-8401-87ceee92a846">
+      <UserInfo>
+        <DisplayName>Office Of Advancement Visitors</DisplayName>
+        <AccountId>4</AccountId>
+        <AccountType/>
+      </UserInfo>
+      <UserInfo>
+        <DisplayName>UCalgary Brand</DisplayName>
+        <AccountId>15</AccountId>
+        <AccountType/>
+      </UserInfo>
+    </SharedWithUsers>
+    <TaxCatchAll xmlns="7a4191d5-9b76-4ae3-8401-87ceee92a846" xsi:nil="true"/>
+    <lcf76f155ced4ddcb4097134ff3c332f xmlns="b9b0194d-1e98-4efc-bad5-9450f4bf7a13">
+      <Terms xmlns="http://schemas.microsoft.com/office/infopath/2007/PartnerControls"/>
+    </lcf76f155ced4ddcb4097134ff3c332f>
+  </documentManagement>
+</p:properties>
+</file>
+
+<file path=customXml/item2.xml><?xml version="1.0" encoding="utf-8"?>
 <ct:contentTypeSchema xmlns:ct="http://schemas.microsoft.com/office/2006/metadata/contentType" xmlns:ma="http://schemas.microsoft.com/office/2006/metadata/properties/metaAttributes" ct:_="" ma:_="" ma:contentTypeName="Document" ma:contentTypeID="0x010100A14D9A0FA515564792FEACC70AB1043E" ma:contentTypeVersion="15" ma:contentTypeDescription="Create a new document." ma:contentTypeScope="" ma:versionID="3387522b3212352fc6bbea455d3cfc53">
   <xsd:schema xmlns:xsd="http://www.w3.org/2001/XMLSchema" xmlns:xs="http://www.w3.org/2001/XMLSchema" xmlns:p="http://schemas.microsoft.com/office/2006/metadata/properties" xmlns:ns2="7a4191d5-9b76-4ae3-8401-87ceee92a846" xmlns:ns3="b9b0194d-1e98-4efc-bad5-9450f4bf7a13" targetNamespace="http://schemas.microsoft.com/office/2006/metadata/properties" ma:root="true" ma:fieldsID="e28e2b4de73025e43726d49ef756c6aa" ns2:_="" ns3:_="">
     <xsd:import namespace="7a4191d5-9b76-4ae3-8401-87ceee92a846"/>
@@ -9288,29 +9441,6 @@
 </ct:contentTypeSchema>
 </file>
 
-<file path=customXml/item2.xml><?xml version="1.0" encoding="utf-8"?>
-<p:properties xmlns:p="http://schemas.microsoft.com/office/2006/metadata/properties" xmlns:xsi="http://www.w3.org/2001/XMLSchema-instance" xmlns:pc="http://schemas.microsoft.com/office/infopath/2007/PartnerControls">
-  <documentManagement>
-    <SharedWithUsers xmlns="7a4191d5-9b76-4ae3-8401-87ceee92a846">
-      <UserInfo>
-        <DisplayName>Office Of Advancement Visitors</DisplayName>
-        <AccountId>4</AccountId>
-        <AccountType/>
-      </UserInfo>
-      <UserInfo>
-        <DisplayName>UCalgary Brand</DisplayName>
-        <AccountId>15</AccountId>
-        <AccountType/>
-      </UserInfo>
-    </SharedWithUsers>
-    <TaxCatchAll xmlns="7a4191d5-9b76-4ae3-8401-87ceee92a846" xsi:nil="true"/>
-    <lcf76f155ced4ddcb4097134ff3c332f xmlns="b9b0194d-1e98-4efc-bad5-9450f4bf7a13">
-      <Terms xmlns="http://schemas.microsoft.com/office/infopath/2007/PartnerControls"/>
-    </lcf76f155ced4ddcb4097134ff3c332f>
-  </documentManagement>
-</p:properties>
-</file>
-
 <file path=customXml/item3.xml><?xml version="1.0" encoding="utf-8"?>
 <?mso-contentType ?>
 <FormTemplates xmlns="http://schemas.microsoft.com/sharepoint/v3/contenttype/forms">
@@ -9321,6 +9451,17 @@
 </file>
 
 <file path=customXml/itemProps1.xml><?xml version="1.0" encoding="utf-8"?>
+<ds:datastoreItem xmlns:ds="http://schemas.openxmlformats.org/officeDocument/2006/customXml" ds:itemID="{836ABDF2-BD05-4010-80BA-3DB41DBF8678}">
+  <ds:schemaRefs>
+    <ds:schemaRef ds:uri="http://schemas.microsoft.com/office/2006/metadata/properties"/>
+    <ds:schemaRef ds:uri="http://schemas.microsoft.com/office/infopath/2007/PartnerControls"/>
+    <ds:schemaRef ds:uri="7a4191d5-9b76-4ae3-8401-87ceee92a846"/>
+    <ds:schemaRef ds:uri="b9b0194d-1e98-4efc-bad5-9450f4bf7a13"/>
+  </ds:schemaRefs>
+</ds:datastoreItem>
+</file>
+
+<file path=customXml/itemProps2.xml><?xml version="1.0" encoding="utf-8"?>
 <ds:datastoreItem xmlns:ds="http://schemas.openxmlformats.org/officeDocument/2006/customXml" ds:itemID="{88FE4E6F-A4E5-40F2-8CE2-36663D7A069E}">
   <ds:schemaRefs>
     <ds:schemaRef ds:uri="http://schemas.microsoft.com/office/2006/metadata/contentType"/>
@@ -9339,17 +9480,6 @@
 </ds:datastoreItem>
 </file>
 
-<file path=customXml/itemProps2.xml><?xml version="1.0" encoding="utf-8"?>
-<ds:datastoreItem xmlns:ds="http://schemas.openxmlformats.org/officeDocument/2006/customXml" ds:itemID="{836ABDF2-BD05-4010-80BA-3DB41DBF8678}">
-  <ds:schemaRefs>
-    <ds:schemaRef ds:uri="http://schemas.microsoft.com/office/2006/metadata/properties"/>
-    <ds:schemaRef ds:uri="http://schemas.microsoft.com/office/infopath/2007/PartnerControls"/>
-    <ds:schemaRef ds:uri="7a4191d5-9b76-4ae3-8401-87ceee92a846"/>
-    <ds:schemaRef ds:uri="b9b0194d-1e98-4efc-bad5-9450f4bf7a13"/>
-  </ds:schemaRefs>
-</ds:datastoreItem>
-</file>
-
 <file path=customXml/itemProps3.xml><?xml version="1.0" encoding="utf-8"?>
 <ds:datastoreItem xmlns:ds="http://schemas.openxmlformats.org/officeDocument/2006/customXml" ds:itemID="{B1379BBF-6672-4ABD-B16E-D222A38B6B94}">
   <ds:schemaRefs>

</xml_diff>

<commit_message>
Corrected temp vs mwh graph
</commit_message>
<xml_diff>
--- a/DATA604/Project/Team Energy Video Presentation.pptx
+++ b/DATA604/Project/Team Energy Video Presentation.pptx
@@ -151,7 +151,7 @@
   <pc:docChgLst>
     <pc:chgData name="Gautham Nagaraj" userId="42582a7dfd2e08c3" providerId="LiveId" clId="{867D6758-E00D-441F-8B1D-675252661ABA}"/>
     <pc:docChg chg="undo redo custSel addSld modSld">
-      <pc:chgData name="Gautham Nagaraj" userId="42582a7dfd2e08c3" providerId="LiveId" clId="{867D6758-E00D-441F-8B1D-675252661ABA}" dt="2025-03-26T17:50:20.172" v="1796" actId="20577"/>
+      <pc:chgData name="Gautham Nagaraj" userId="42582a7dfd2e08c3" providerId="LiveId" clId="{867D6758-E00D-441F-8B1D-675252661ABA}" dt="2025-03-26T20:07:55.132" v="1801" actId="1076"/>
       <pc:docMkLst>
         <pc:docMk/>
       </pc:docMkLst>
@@ -389,7 +389,7 @@
         </pc:spChg>
       </pc:sldChg>
       <pc:sldChg chg="addSp delSp modSp new mod">
-        <pc:chgData name="Gautham Nagaraj" userId="42582a7dfd2e08c3" providerId="LiveId" clId="{867D6758-E00D-441F-8B1D-675252661ABA}" dt="2025-03-26T17:44:04.622" v="1769" actId="14100"/>
+        <pc:chgData name="Gautham Nagaraj" userId="42582a7dfd2e08c3" providerId="LiveId" clId="{867D6758-E00D-441F-8B1D-675252661ABA}" dt="2025-03-26T20:07:55.132" v="1801" actId="1076"/>
         <pc:sldMkLst>
           <pc:docMk/>
           <pc:sldMk cId="2670562210" sldId="267"/>
@@ -411,7 +411,15 @@
           </ac:spMkLst>
         </pc:spChg>
         <pc:picChg chg="add mod">
-          <ac:chgData name="Gautham Nagaraj" userId="42582a7dfd2e08c3" providerId="LiveId" clId="{867D6758-E00D-441F-8B1D-675252661ABA}" dt="2025-03-26T17:44:04.622" v="1769" actId="14100"/>
+          <ac:chgData name="Gautham Nagaraj" userId="42582a7dfd2e08c3" providerId="LiveId" clId="{867D6758-E00D-441F-8B1D-675252661ABA}" dt="2025-03-26T20:07:55.132" v="1801" actId="1076"/>
+          <ac:picMkLst>
+            <pc:docMk/>
+            <pc:sldMk cId="2670562210" sldId="267"/>
+            <ac:picMk id="5" creationId="{AEC2618F-E377-D13E-CF7A-B93CDB23F183}"/>
+          </ac:picMkLst>
+        </pc:picChg>
+        <pc:picChg chg="add del mod">
+          <ac:chgData name="Gautham Nagaraj" userId="42582a7dfd2e08c3" providerId="LiveId" clId="{867D6758-E00D-441F-8B1D-675252661ABA}" dt="2025-03-26T20:07:46.271" v="1797" actId="478"/>
           <ac:picMkLst>
             <pc:docMk/>
             <pc:sldMk cId="2670562210" sldId="267"/>
@@ -6749,10 +6757,10 @@
       </p:sp>
       <p:pic>
         <p:nvPicPr>
-          <p:cNvPr id="6" name="Picture 5">
+          <p:cNvPr id="5" name="Picture 4">
             <a:extLst>
               <a:ext uri="{FF2B5EF4-FFF2-40B4-BE49-F238E27FC236}">
-                <a16:creationId xmlns:a16="http://schemas.microsoft.com/office/drawing/2014/main" id="{1B4E3A50-80E6-6BF5-4E1B-0B5301EA9F8C}"/>
+                <a16:creationId xmlns:a16="http://schemas.microsoft.com/office/drawing/2014/main" id="{AEC2618F-E377-D13E-CF7A-B93CDB23F183}"/>
               </a:ext>
             </a:extLst>
           </p:cNvPr>
@@ -6769,8 +6777,8 @@
         </p:blipFill>
         <p:spPr>
           <a:xfrm>
-            <a:off x="1070043" y="2269631"/>
-            <a:ext cx="8570067" cy="4588369"/>
+            <a:off x="963038" y="2200902"/>
+            <a:ext cx="9068606" cy="4657098"/>
           </a:xfrm>
           <a:prstGeom prst="rect">
             <a:avLst/>
@@ -9196,29 +9204,6 @@
 </file>
 
 <file path=customXml/item1.xml><?xml version="1.0" encoding="utf-8"?>
-<p:properties xmlns:p="http://schemas.microsoft.com/office/2006/metadata/properties" xmlns:xsi="http://www.w3.org/2001/XMLSchema-instance" xmlns:pc="http://schemas.microsoft.com/office/infopath/2007/PartnerControls">
-  <documentManagement>
-    <SharedWithUsers xmlns="7a4191d5-9b76-4ae3-8401-87ceee92a846">
-      <UserInfo>
-        <DisplayName>Office Of Advancement Visitors</DisplayName>
-        <AccountId>4</AccountId>
-        <AccountType/>
-      </UserInfo>
-      <UserInfo>
-        <DisplayName>UCalgary Brand</DisplayName>
-        <AccountId>15</AccountId>
-        <AccountType/>
-      </UserInfo>
-    </SharedWithUsers>
-    <TaxCatchAll xmlns="7a4191d5-9b76-4ae3-8401-87ceee92a846" xsi:nil="true"/>
-    <lcf76f155ced4ddcb4097134ff3c332f xmlns="b9b0194d-1e98-4efc-bad5-9450f4bf7a13">
-      <Terms xmlns="http://schemas.microsoft.com/office/infopath/2007/PartnerControls"/>
-    </lcf76f155ced4ddcb4097134ff3c332f>
-  </documentManagement>
-</p:properties>
-</file>
-
-<file path=customXml/item2.xml><?xml version="1.0" encoding="utf-8"?>
 <ct:contentTypeSchema xmlns:ct="http://schemas.microsoft.com/office/2006/metadata/contentType" xmlns:ma="http://schemas.microsoft.com/office/2006/metadata/properties/metaAttributes" ct:_="" ma:_="" ma:contentTypeName="Document" ma:contentTypeID="0x010100A14D9A0FA515564792FEACC70AB1043E" ma:contentTypeVersion="15" ma:contentTypeDescription="Create a new document." ma:contentTypeScope="" ma:versionID="3387522b3212352fc6bbea455d3cfc53">
   <xsd:schema xmlns:xsd="http://www.w3.org/2001/XMLSchema" xmlns:xs="http://www.w3.org/2001/XMLSchema" xmlns:p="http://schemas.microsoft.com/office/2006/metadata/properties" xmlns:ns2="7a4191d5-9b76-4ae3-8401-87ceee92a846" xmlns:ns3="b9b0194d-1e98-4efc-bad5-9450f4bf7a13" targetNamespace="http://schemas.microsoft.com/office/2006/metadata/properties" ma:root="true" ma:fieldsID="e28e2b4de73025e43726d49ef756c6aa" ns2:_="" ns3:_="">
     <xsd:import namespace="7a4191d5-9b76-4ae3-8401-87ceee92a846"/>
@@ -9441,6 +9426,29 @@
 </ct:contentTypeSchema>
 </file>
 
+<file path=customXml/item2.xml><?xml version="1.0" encoding="utf-8"?>
+<p:properties xmlns:p="http://schemas.microsoft.com/office/2006/metadata/properties" xmlns:xsi="http://www.w3.org/2001/XMLSchema-instance" xmlns:pc="http://schemas.microsoft.com/office/infopath/2007/PartnerControls">
+  <documentManagement>
+    <SharedWithUsers xmlns="7a4191d5-9b76-4ae3-8401-87ceee92a846">
+      <UserInfo>
+        <DisplayName>Office Of Advancement Visitors</DisplayName>
+        <AccountId>4</AccountId>
+        <AccountType/>
+      </UserInfo>
+      <UserInfo>
+        <DisplayName>UCalgary Brand</DisplayName>
+        <AccountId>15</AccountId>
+        <AccountType/>
+      </UserInfo>
+    </SharedWithUsers>
+    <TaxCatchAll xmlns="7a4191d5-9b76-4ae3-8401-87ceee92a846" xsi:nil="true"/>
+    <lcf76f155ced4ddcb4097134ff3c332f xmlns="b9b0194d-1e98-4efc-bad5-9450f4bf7a13">
+      <Terms xmlns="http://schemas.microsoft.com/office/infopath/2007/PartnerControls"/>
+    </lcf76f155ced4ddcb4097134ff3c332f>
+  </documentManagement>
+</p:properties>
+</file>
+
 <file path=customXml/item3.xml><?xml version="1.0" encoding="utf-8"?>
 <?mso-contentType ?>
 <FormTemplates xmlns="http://schemas.microsoft.com/sharepoint/v3/contenttype/forms">
@@ -9451,17 +9459,6 @@
 </file>
 
 <file path=customXml/itemProps1.xml><?xml version="1.0" encoding="utf-8"?>
-<ds:datastoreItem xmlns:ds="http://schemas.openxmlformats.org/officeDocument/2006/customXml" ds:itemID="{836ABDF2-BD05-4010-80BA-3DB41DBF8678}">
-  <ds:schemaRefs>
-    <ds:schemaRef ds:uri="http://schemas.microsoft.com/office/2006/metadata/properties"/>
-    <ds:schemaRef ds:uri="http://schemas.microsoft.com/office/infopath/2007/PartnerControls"/>
-    <ds:schemaRef ds:uri="7a4191d5-9b76-4ae3-8401-87ceee92a846"/>
-    <ds:schemaRef ds:uri="b9b0194d-1e98-4efc-bad5-9450f4bf7a13"/>
-  </ds:schemaRefs>
-</ds:datastoreItem>
-</file>
-
-<file path=customXml/itemProps2.xml><?xml version="1.0" encoding="utf-8"?>
 <ds:datastoreItem xmlns:ds="http://schemas.openxmlformats.org/officeDocument/2006/customXml" ds:itemID="{88FE4E6F-A4E5-40F2-8CE2-36663D7A069E}">
   <ds:schemaRefs>
     <ds:schemaRef ds:uri="http://schemas.microsoft.com/office/2006/metadata/contentType"/>
@@ -9480,6 +9477,17 @@
 </ds:datastoreItem>
 </file>
 
+<file path=customXml/itemProps2.xml><?xml version="1.0" encoding="utf-8"?>
+<ds:datastoreItem xmlns:ds="http://schemas.openxmlformats.org/officeDocument/2006/customXml" ds:itemID="{836ABDF2-BD05-4010-80BA-3DB41DBF8678}">
+  <ds:schemaRefs>
+    <ds:schemaRef ds:uri="http://schemas.microsoft.com/office/2006/metadata/properties"/>
+    <ds:schemaRef ds:uri="http://schemas.microsoft.com/office/infopath/2007/PartnerControls"/>
+    <ds:schemaRef ds:uri="7a4191d5-9b76-4ae3-8401-87ceee92a846"/>
+    <ds:schemaRef ds:uri="b9b0194d-1e98-4efc-bad5-9450f4bf7a13"/>
+  </ds:schemaRefs>
+</ds:datastoreItem>
+</file>
+
 <file path=customXml/itemProps3.xml><?xml version="1.0" encoding="utf-8"?>
 <ds:datastoreItem xmlns:ds="http://schemas.openxmlformats.org/officeDocument/2006/customXml" ds:itemID="{B1379BBF-6672-4ABD-B16E-D222A38B6B94}">
   <ds:schemaRefs>

</xml_diff>